<commit_message>
docs(presentation): complete 17-slide executive presentation with real screenshots of login and all core features
</commit_message>
<xml_diff>
--- a/QuickShare_Project_Presentation.pptx
+++ b/QuickShare_Project_Presentation.pptx
@@ -18,6 +18,10 @@
     <p:sldId id="266" r:id="rId17"/>
     <p:sldId id="267" r:id="rId18"/>
     <p:sldId id="268" r:id="rId19"/>
+    <p:sldId id="269" r:id="rId20"/>
+    <p:sldId id="270" r:id="rId21"/>
+    <p:sldId id="271" r:id="rId22"/>
+    <p:sldId id="272" r:id="rId23"/>
   </p:sldIdLst>
   <p:sldSz cx="12191695" cy="6858000" type="screen4x3"/>
   <p:notesSz cx="6858000" cy="9144000"/>
@@ -3344,7 +3348,7 @@
               </a:defRPr>
             </a:pPr>
             <a:r>
-              <a:t>Zero-Login 6-Digit Transfers, Recipient Inboxes, Study Groups &amp; Personal Cloud Drive</a:t>
+              <a:t>Zero-Login 6-Digit Transfers, Recipient Inboxes, Collaboration Groups &amp; Personal Cloud Drive</a:t>
             </a:r>
           </a:p>
         </p:txBody>
@@ -3617,7 +3621,7 @@
               </a:defRPr>
             </a:pPr>
             <a:r>
-              <a:t>REAL APPLICATION INTERFACE</a:t>
+              <a:t>CLOUD FILE STORAGE</a:t>
             </a:r>
           </a:p>
         </p:txBody>
@@ -3653,7 +3657,7 @@
               </a:defRPr>
             </a:pPr>
             <a:r>
-              <a:t>Night Mode &amp; Visual Accessibility</a:t>
+              <a:t>Personal Cloud Drive &amp; Storage Lifecycle</a:t>
             </a:r>
           </a:p>
           <a:p>
@@ -3669,14 +3673,14 @@
               </a:defRPr>
             </a:pPr>
             <a:r>
-              <a:t>Live desktop screenshot showing the high-contrast dark theme.</a:t>
+              <a:t>Live application screenshot of the personal file management console.</a:t>
             </a:r>
           </a:p>
         </p:txBody>
       </p:sp>
       <p:pic>
         <p:nvPicPr>
-          <p:cNvPr id="5" name="Picture 4" descr="09_night_mode_dashboard.png"/>
+          <p:cNvPr id="5" name="Picture 4" descr="screen_07_my_files.png"/>
           <p:cNvPicPr>
             <a:picLocks noChangeAspect="1"/>
           </p:cNvPicPr>
@@ -3774,7 +3778,7 @@
               </a:defRPr>
             </a:pPr>
             <a:r>
-              <a:t>Visual Design &amp; Accessibility Features</a:t>
+              <a:t>File Management &amp; Quota Tracking</a:t>
             </a:r>
           </a:p>
           <a:p>
@@ -3790,7 +3794,7 @@
               </a:defRPr>
             </a:pPr>
             <a:r>
-              <a:t>• Ambient radial canvas: Subtle depth mesh designed for extended use.</a:t>
+              <a:t>• Free storage quota: Live progress bar tracking usage (1024 MB quota).</a:t>
             </a:r>
           </a:p>
           <a:p>
@@ -3806,7 +3810,7 @@
               </a:defRPr>
             </a:pPr>
             <a:r>
-              <a:t>• 1-Click theme toggle: Instant switch between Day (Light) and Night (Dark) mode.</a:t>
+              <a:t>• Smart category filtering: All Files, Images, Documents, Media, and Archives.</a:t>
             </a:r>
           </a:p>
           <a:p>
@@ -3822,7 +3826,7 @@
               </a:defRPr>
             </a:pPr>
             <a:r>
-              <a:t>• Persistent user preference: Saved in browser local storage automatically.</a:t>
+              <a:t>• Trash Bin management: Soft-delete files with 1-click instant restoration.</a:t>
             </a:r>
           </a:p>
           <a:p>
@@ -3838,7 +3842,7 @@
               </a:defRPr>
             </a:pPr>
             <a:r>
-              <a:t>• WCAG-compliant contrast: High-contrast text ensures readable code displays.</a:t>
+              <a:t>• Inline rename: Edit file names directly without re-uploading.</a:t>
             </a:r>
           </a:p>
           <a:p>
@@ -3854,7 +3858,7 @@
               </a:defRPr>
             </a:pPr>
             <a:r>
-              <a:t>• Reduced eye strain: Optimal for evening study sessions and low-light labs.</a:t>
+              <a:t>• Secret owner delete key: 24-byte cryptographic token for immediate purge.</a:t>
             </a:r>
           </a:p>
           <a:p>
@@ -3870,7 +3874,7 @@
               </a:defRPr>
             </a:pPr>
             <a:r>
-              <a:t>• Consistent UI language across all modals, drawers, and form controls.</a:t>
+              <a:t>• Full audit details: View download counts, creation dates, and expiration times.</a:t>
             </a:r>
           </a:p>
         </p:txBody>
@@ -3967,7 +3971,7 @@
               </a:defRPr>
             </a:pPr>
             <a:r>
-              <a:t>ENGINEERING SPECIFICATIONS</a:t>
+              <a:t>CONFIDENTIAL PURGE</a:t>
             </a:r>
           </a:p>
         </p:txBody>
@@ -4003,7 +4007,7 @@
               </a:defRPr>
             </a:pPr>
             <a:r>
-              <a:t>Technology Stack &amp; ₹0 Cloud Economics</a:t>
+              <a:t>Secret Key Deletion: Emergency File Purge</a:t>
             </a:r>
           </a:p>
           <a:p>
@@ -4019,21 +4023,45 @@
               </a:defRPr>
             </a:pPr>
             <a:r>
-              <a:t>Demonstrating modern architectural efficiency with zero financial overhead.</a:t>
-            </a:r>
-          </a:p>
-        </p:txBody>
-      </p:sp>
-      <p:sp>
-        <p:nvSpPr>
-          <p:cNvPr id="5" name="Rounded Rectangle 4"/>
+              <a:t>Live application screenshot of the Delete with Key modal.</a:t>
+            </a:r>
+          </a:p>
+        </p:txBody>
+      </p:sp>
+      <p:pic>
+        <p:nvPicPr>
+          <p:cNvPr id="5" name="Picture 4" descr="screen_02_revoke_modal.png"/>
+          <p:cNvPicPr>
+            <a:picLocks noChangeAspect="1"/>
+          </p:cNvPicPr>
+          <p:nvPr/>
+        </p:nvPicPr>
+        <p:blipFill>
+          <a:blip r:embed="rId2"/>
+          <a:stretch>
+            <a:fillRect/>
+          </a:stretch>
+        </p:blipFill>
+        <p:spPr>
+          <a:xfrm>
+            <a:off x="731520" y="1645920"/>
+            <a:ext cx="6858000" cy="4572000"/>
+          </a:xfrm>
+          <a:prstGeom prst="rect">
+            <a:avLst/>
+          </a:prstGeom>
+        </p:spPr>
+      </p:pic>
+      <p:sp>
+        <p:nvSpPr>
+          <p:cNvPr id="6" name="Rounded Rectangle 5"/>
           <p:cNvSpPr/>
           <p:nvPr/>
         </p:nvSpPr>
         <p:spPr>
           <a:xfrm>
-            <a:off x="731520" y="1645920"/>
-            <a:ext cx="2011680" cy="4389120"/>
+            <a:off x="7863840" y="1645920"/>
+            <a:ext cx="3566160" cy="4572000"/>
           </a:xfrm>
           <a:prstGeom prst="roundRect">
             <a:avLst/>
@@ -4041,7 +4069,7 @@
           <a:solidFill>
             <a:srgbClr val="1E293B"/>
           </a:solidFill>
-          <a:ln>
+          <a:ln w="12700">
             <a:solidFill>
               <a:srgbClr val="334155"/>
             </a:solidFill>
@@ -4071,14 +4099,14 @@
       </p:sp>
       <p:sp>
         <p:nvSpPr>
-          <p:cNvPr id="6" name="TextBox 5"/>
+          <p:cNvPr id="7" name="TextBox 6"/>
           <p:cNvSpPr txBox="1"/>
           <p:nvPr/>
         </p:nvSpPr>
         <p:spPr>
           <a:xfrm>
-            <a:off x="868680" y="1920240"/>
-            <a:ext cx="1737360" cy="3840480"/>
+            <a:off x="8183880" y="1874519"/>
+            <a:ext cx="2926080" cy="4114800"/>
           </a:xfrm>
           <a:prstGeom prst="rect">
             <a:avLst/>
@@ -4091,8 +4119,8 @@
           </a:bodyPr>
           <a:lstStyle/>
           <a:p>
-            <a:pPr algn="ctr">
-              <a:defRPr sz="2600" b="1">
+            <a:pPr>
+              <a:defRPr sz="1400" b="1">
                 <a:solidFill>
                   <a:srgbClr val="F43F5E"/>
                 </a:solidFill>
@@ -4100,521 +4128,103 @@
               </a:defRPr>
             </a:pPr>
             <a:r>
-              <a:t>₹0 / Month</a:t>
-            </a:r>
-          </a:p>
-          <a:p>
-            <a:pPr algn="ctr">
-              <a:spcBef>
-                <a:spcPts val="800"/>
-              </a:spcBef>
-              <a:defRPr sz="1200" b="1">
-                <a:solidFill>
-                  <a:srgbClr val="FFFFFF"/>
-                </a:solidFill>
-              </a:defRPr>
-            </a:pPr>
-            <a:r>
-              <a:t>Total Hosting Cost</a:t>
-            </a:r>
-          </a:p>
-          <a:p>
-            <a:pPr algn="ctr">
-              <a:spcBef>
-                <a:spcPts val="1400"/>
-              </a:spcBef>
-              <a:defRPr sz="1100">
-                <a:solidFill>
-                  <a:srgbClr val="94A3B8"/>
-                </a:solidFill>
-              </a:defRPr>
-            </a:pPr>
-            <a:r>
-              <a:t>100% Free Forever</a:t>
-            </a:r>
-            <a:br/>
-            <a:r>
-              <a:t>No credit card required</a:t>
-            </a:r>
-            <a:br/>
-            <a:r>
-              <a:t>Production-ready SLA</a:t>
-            </a:r>
-          </a:p>
-        </p:txBody>
-      </p:sp>
-      <p:sp>
-        <p:nvSpPr>
-          <p:cNvPr id="7" name="Rounded Rectangle 6"/>
-          <p:cNvSpPr/>
-          <p:nvPr/>
-        </p:nvSpPr>
-        <p:spPr>
-          <a:xfrm>
-            <a:off x="2907791" y="1645920"/>
-            <a:ext cx="2011680" cy="4389120"/>
-          </a:xfrm>
-          <a:prstGeom prst="roundRect">
-            <a:avLst/>
-          </a:prstGeom>
-          <a:solidFill>
-            <a:srgbClr val="1E293B"/>
-          </a:solidFill>
-          <a:ln>
-            <a:solidFill>
-              <a:srgbClr val="334155"/>
-            </a:solidFill>
-          </a:ln>
-        </p:spPr>
-        <p:style>
-          <a:lnRef idx="1">
-            <a:schemeClr val="accent1"/>
-          </a:lnRef>
-          <a:fillRef idx="3">
-            <a:schemeClr val="accent1"/>
-          </a:fillRef>
-          <a:effectRef idx="2">
-            <a:schemeClr val="accent1"/>
-          </a:effectRef>
-          <a:fontRef idx="minor">
-            <a:schemeClr val="lt1"/>
-          </a:fontRef>
-        </p:style>
-        <p:txBody>
-          <a:bodyPr rtlCol="0" anchor="ctr"/>
-          <a:lstStyle/>
-          <a:p>
-            <a:pPr algn="ctr"/>
-          </a:p>
-        </p:txBody>
-      </p:sp>
-      <p:sp>
-        <p:nvSpPr>
-          <p:cNvPr id="8" name="TextBox 7"/>
-          <p:cNvSpPr txBox="1"/>
-          <p:nvPr/>
-        </p:nvSpPr>
-        <p:spPr>
-          <a:xfrm>
-            <a:off x="3044951" y="1920240"/>
-            <a:ext cx="1737360" cy="3840480"/>
-          </a:xfrm>
-          <a:prstGeom prst="rect">
-            <a:avLst/>
-          </a:prstGeom>
-          <a:noFill/>
-        </p:spPr>
-        <p:txBody>
-          <a:bodyPr wrap="square">
-            <a:spAutoFit/>
-          </a:bodyPr>
-          <a:lstStyle/>
-          <a:p>
-            <a:pPr algn="ctr">
-              <a:defRPr sz="2600" b="1">
-                <a:solidFill>
-                  <a:srgbClr val="818CF8"/>
-                </a:solidFill>
-                <a:latin typeface="Segoe UI"/>
-              </a:defRPr>
-            </a:pPr>
-            <a:r>
-              <a:t>100 GB</a:t>
-            </a:r>
-          </a:p>
-          <a:p>
-            <a:pPr algn="ctr">
-              <a:spcBef>
-                <a:spcPts val="800"/>
-              </a:spcBef>
-              <a:defRPr sz="1200" b="1">
-                <a:solidFill>
-                  <a:srgbClr val="FFFFFF"/>
-                </a:solidFill>
-              </a:defRPr>
-            </a:pPr>
-            <a:r>
-              <a:t>Vercel Edge CDN</a:t>
-            </a:r>
-          </a:p>
-          <a:p>
-            <a:pPr algn="ctr">
-              <a:spcBef>
-                <a:spcPts val="1400"/>
-              </a:spcBef>
-              <a:defRPr sz="1100">
-                <a:solidFill>
-                  <a:srgbClr val="94A3B8"/>
-                </a:solidFill>
-              </a:defRPr>
-            </a:pPr>
-            <a:r>
-              <a:t>React 18 &amp; Vite SPA</a:t>
-            </a:r>
-            <a:br/>
-            <a:r>
-              <a:t>Global edge caching</a:t>
-            </a:r>
-            <a:br/>
-            <a:r>
-              <a:t>Automatic SSL &amp; CI/CD</a:t>
-            </a:r>
-          </a:p>
-        </p:txBody>
-      </p:sp>
-      <p:sp>
-        <p:nvSpPr>
-          <p:cNvPr id="9" name="Rounded Rectangle 8"/>
-          <p:cNvSpPr/>
-          <p:nvPr/>
-        </p:nvSpPr>
-        <p:spPr>
-          <a:xfrm>
-            <a:off x="5084064" y="1645920"/>
-            <a:ext cx="2011680" cy="4389120"/>
-          </a:xfrm>
-          <a:prstGeom prst="roundRect">
-            <a:avLst/>
-          </a:prstGeom>
-          <a:solidFill>
-            <a:srgbClr val="1E293B"/>
-          </a:solidFill>
-          <a:ln>
-            <a:solidFill>
-              <a:srgbClr val="334155"/>
-            </a:solidFill>
-          </a:ln>
-        </p:spPr>
-        <p:style>
-          <a:lnRef idx="1">
-            <a:schemeClr val="accent1"/>
-          </a:lnRef>
-          <a:fillRef idx="3">
-            <a:schemeClr val="accent1"/>
-          </a:fillRef>
-          <a:effectRef idx="2">
-            <a:schemeClr val="accent1"/>
-          </a:effectRef>
-          <a:fontRef idx="minor">
-            <a:schemeClr val="lt1"/>
-          </a:fontRef>
-        </p:style>
-        <p:txBody>
-          <a:bodyPr rtlCol="0" anchor="ctr"/>
-          <a:lstStyle/>
-          <a:p>
-            <a:pPr algn="ctr"/>
-          </a:p>
-        </p:txBody>
-      </p:sp>
-      <p:sp>
-        <p:nvSpPr>
-          <p:cNvPr id="10" name="TextBox 9"/>
-          <p:cNvSpPr txBox="1"/>
-          <p:nvPr/>
-        </p:nvSpPr>
-        <p:spPr>
-          <a:xfrm>
-            <a:off x="5221224" y="1920240"/>
-            <a:ext cx="1737360" cy="3840480"/>
-          </a:xfrm>
-          <a:prstGeom prst="rect">
-            <a:avLst/>
-          </a:prstGeom>
-          <a:noFill/>
-        </p:spPr>
-        <p:txBody>
-          <a:bodyPr wrap="square">
-            <a:spAutoFit/>
-          </a:bodyPr>
-          <a:lstStyle/>
-          <a:p>
-            <a:pPr algn="ctr">
-              <a:defRPr sz="2600" b="1">
-                <a:solidFill>
-                  <a:srgbClr val="10B981"/>
-                </a:solidFill>
-                <a:latin typeface="Segoe UI"/>
-              </a:defRPr>
-            </a:pPr>
-            <a:r>
-              <a:t>512 MB</a:t>
-            </a:r>
-          </a:p>
-          <a:p>
-            <a:pPr algn="ctr">
-              <a:spcBef>
-                <a:spcPts val="800"/>
-              </a:spcBef>
-              <a:defRPr sz="1200" b="1">
-                <a:solidFill>
-                  <a:srgbClr val="FFFFFF"/>
-                </a:solidFill>
-              </a:defRPr>
-            </a:pPr>
-            <a:r>
-              <a:t>Render API Service</a:t>
-            </a:r>
-          </a:p>
-          <a:p>
-            <a:pPr algn="ctr">
-              <a:spcBef>
-                <a:spcPts val="1400"/>
-              </a:spcBef>
-              <a:defRPr sz="1100">
-                <a:solidFill>
-                  <a:srgbClr val="94A3B8"/>
-                </a:solidFill>
-              </a:defRPr>
-            </a:pPr>
-            <a:r>
-              <a:t>Node.js 22+ &amp; Express</a:t>
-            </a:r>
-            <a:br/>
-            <a:r>
-              <a:t>REST API &amp; WebSockets</a:t>
-            </a:r>
-            <a:br/>
-            <a:r>
-              <a:t>750 free hours/month</a:t>
-            </a:r>
-          </a:p>
-        </p:txBody>
-      </p:sp>
-      <p:sp>
-        <p:nvSpPr>
-          <p:cNvPr id="11" name="Rounded Rectangle 10"/>
-          <p:cNvSpPr/>
-          <p:nvPr/>
-        </p:nvSpPr>
-        <p:spPr>
-          <a:xfrm>
-            <a:off x="7260336" y="1645920"/>
-            <a:ext cx="2011680" cy="4389120"/>
-          </a:xfrm>
-          <a:prstGeom prst="roundRect">
-            <a:avLst/>
-          </a:prstGeom>
-          <a:solidFill>
-            <a:srgbClr val="1E293B"/>
-          </a:solidFill>
-          <a:ln>
-            <a:solidFill>
-              <a:srgbClr val="334155"/>
-            </a:solidFill>
-          </a:ln>
-        </p:spPr>
-        <p:style>
-          <a:lnRef idx="1">
-            <a:schemeClr val="accent1"/>
-          </a:lnRef>
-          <a:fillRef idx="3">
-            <a:schemeClr val="accent1"/>
-          </a:fillRef>
-          <a:effectRef idx="2">
-            <a:schemeClr val="accent1"/>
-          </a:effectRef>
-          <a:fontRef idx="minor">
-            <a:schemeClr val="lt1"/>
-          </a:fontRef>
-        </p:style>
-        <p:txBody>
-          <a:bodyPr rtlCol="0" anchor="ctr"/>
-          <a:lstStyle/>
-          <a:p>
-            <a:pPr algn="ctr"/>
-          </a:p>
-        </p:txBody>
-      </p:sp>
-      <p:sp>
-        <p:nvSpPr>
-          <p:cNvPr id="12" name="TextBox 11"/>
-          <p:cNvSpPr txBox="1"/>
-          <p:nvPr/>
-        </p:nvSpPr>
-        <p:spPr>
-          <a:xfrm>
-            <a:off x="7397496" y="1920240"/>
-            <a:ext cx="1737360" cy="3840480"/>
-          </a:xfrm>
-          <a:prstGeom prst="rect">
-            <a:avLst/>
-          </a:prstGeom>
-          <a:noFill/>
-        </p:spPr>
-        <p:txBody>
-          <a:bodyPr wrap="square">
-            <a:spAutoFit/>
-          </a:bodyPr>
-          <a:lstStyle/>
-          <a:p>
-            <a:pPr algn="ctr">
-              <a:defRPr sz="2600" b="1">
-                <a:solidFill>
-                  <a:srgbClr val="F43F5E"/>
-                </a:solidFill>
-                <a:latin typeface="Segoe UI"/>
-              </a:defRPr>
-            </a:pPr>
-            <a:r>
-              <a:t>5 GB</a:t>
-            </a:r>
-          </a:p>
-          <a:p>
-            <a:pPr algn="ctr">
-              <a:spcBef>
-                <a:spcPts val="800"/>
-              </a:spcBef>
-              <a:defRPr sz="1200" b="1">
-                <a:solidFill>
-                  <a:srgbClr val="FFFFFF"/>
-                </a:solidFill>
-              </a:defRPr>
-            </a:pPr>
-            <a:r>
-              <a:t>TiDB Serverless</a:t>
-            </a:r>
-          </a:p>
-          <a:p>
-            <a:pPr algn="ctr">
-              <a:spcBef>
-                <a:spcPts val="1400"/>
-              </a:spcBef>
-              <a:defRPr sz="1100">
-                <a:solidFill>
-                  <a:srgbClr val="94A3B8"/>
-                </a:solidFill>
-              </a:defRPr>
-            </a:pPr>
-            <a:r>
-              <a:t>Cloud MySQL 8 engine</a:t>
-            </a:r>
-            <a:br/>
-            <a:r>
-              <a:t>50M Request Units/month</a:t>
-            </a:r>
-            <a:br/>
-            <a:r>
-              <a:t>Dual SQLite dev driver</a:t>
-            </a:r>
-          </a:p>
-        </p:txBody>
-      </p:sp>
-      <p:sp>
-        <p:nvSpPr>
-          <p:cNvPr id="13" name="Rounded Rectangle 12"/>
-          <p:cNvSpPr/>
-          <p:nvPr/>
-        </p:nvSpPr>
-        <p:spPr>
-          <a:xfrm>
-            <a:off x="9436608" y="1645920"/>
-            <a:ext cx="2011680" cy="4389120"/>
-          </a:xfrm>
-          <a:prstGeom prst="roundRect">
-            <a:avLst/>
-          </a:prstGeom>
-          <a:solidFill>
-            <a:srgbClr val="1E293B"/>
-          </a:solidFill>
-          <a:ln>
-            <a:solidFill>
-              <a:srgbClr val="334155"/>
-            </a:solidFill>
-          </a:ln>
-        </p:spPr>
-        <p:style>
-          <a:lnRef idx="1">
-            <a:schemeClr val="accent1"/>
-          </a:lnRef>
-          <a:fillRef idx="3">
-            <a:schemeClr val="accent1"/>
-          </a:fillRef>
-          <a:effectRef idx="2">
-            <a:schemeClr val="accent1"/>
-          </a:effectRef>
-          <a:fontRef idx="minor">
-            <a:schemeClr val="lt1"/>
-          </a:fontRef>
-        </p:style>
-        <p:txBody>
-          <a:bodyPr rtlCol="0" anchor="ctr"/>
-          <a:lstStyle/>
-          <a:p>
-            <a:pPr algn="ctr"/>
-          </a:p>
-        </p:txBody>
-      </p:sp>
-      <p:sp>
-        <p:nvSpPr>
-          <p:cNvPr id="14" name="TextBox 13"/>
-          <p:cNvSpPr txBox="1"/>
-          <p:nvPr/>
-        </p:nvSpPr>
-        <p:spPr>
-          <a:xfrm>
-            <a:off x="9573768" y="1920240"/>
-            <a:ext cx="1737360" cy="3840480"/>
-          </a:xfrm>
-          <a:prstGeom prst="rect">
-            <a:avLst/>
-          </a:prstGeom>
-          <a:noFill/>
-        </p:spPr>
-        <p:txBody>
-          <a:bodyPr wrap="square">
-            <a:spAutoFit/>
-          </a:bodyPr>
-          <a:lstStyle/>
-          <a:p>
-            <a:pPr algn="ctr">
-              <a:defRPr sz="2600" b="1">
-                <a:solidFill>
-                  <a:srgbClr val="818CF8"/>
-                </a:solidFill>
-                <a:latin typeface="Segoe UI"/>
-              </a:defRPr>
-            </a:pPr>
-            <a:r>
-              <a:t>1 GB</a:t>
-            </a:r>
-          </a:p>
-          <a:p>
-            <a:pPr algn="ctr">
-              <a:spcBef>
-                <a:spcPts val="800"/>
-              </a:spcBef>
-              <a:defRPr sz="1200" b="1">
-                <a:solidFill>
-                  <a:srgbClr val="FFFFFF"/>
-                </a:solidFill>
-              </a:defRPr>
-            </a:pPr>
-            <a:r>
-              <a:t>Supabase S3 Storage</a:t>
-            </a:r>
-          </a:p>
-          <a:p>
-            <a:pPr algn="ctr">
-              <a:spcBef>
-                <a:spcPts val="1400"/>
-              </a:spcBef>
-              <a:defRPr sz="1100">
-                <a:solidFill>
-                  <a:srgbClr val="94A3B8"/>
-                </a:solidFill>
-              </a:defRPr>
-            </a:pPr>
-            <a:r>
-              <a:t>S3-compatible bucket</a:t>
-            </a:r>
-            <a:br/>
-            <a:r>
-              <a:t>Streaming downloads</a:t>
-            </a:r>
-            <a:br/>
-            <a:r>
-              <a:t>Automated purge cron</a:t>
+              <a:t>Emergency Purge Workflow</a:t>
+            </a:r>
+          </a:p>
+          <a:p>
+            <a:pPr>
+              <a:spcBef>
+                <a:spcPts val="600"/>
+              </a:spcBef>
+              <a:defRPr sz="1100">
+                <a:solidFill>
+                  <a:srgbClr val="E2E8F0"/>
+                </a:solidFill>
+                <a:latin typeface="Segoe UI"/>
+              </a:defRPr>
+            </a:pPr>
+            <a:r>
+              <a:t>• Private 24-Byte Token: Generated automatically during file upload.</a:t>
+            </a:r>
+          </a:p>
+          <a:p>
+            <a:pPr>
+              <a:spcBef>
+                <a:spcPts val="600"/>
+              </a:spcBef>
+              <a:defRPr sz="1100">
+                <a:solidFill>
+                  <a:srgbClr val="E2E8F0"/>
+                </a:solidFill>
+                <a:latin typeface="Segoe UI"/>
+              </a:defRPr>
+            </a:pPr>
+            <a:r>
+              <a:t>• Cross-Device Deletion: Enter the key from any browser to destroy files early.</a:t>
+            </a:r>
+          </a:p>
+          <a:p>
+            <a:pPr>
+              <a:spcBef>
+                <a:spcPts val="600"/>
+              </a:spcBef>
+              <a:defRPr sz="1100">
+                <a:solidFill>
+                  <a:srgbClr val="E2E8F0"/>
+                </a:solidFill>
+                <a:latin typeface="Segoe UI"/>
+              </a:defRPr>
+            </a:pPr>
+            <a:r>
+              <a:t>• Immediate S3 Purge: File binaries are immediately deleted from cloud storage.</a:t>
+            </a:r>
+          </a:p>
+          <a:p>
+            <a:pPr>
+              <a:spcBef>
+                <a:spcPts val="600"/>
+              </a:spcBef>
+              <a:defRPr sz="1100">
+                <a:solidFill>
+                  <a:srgbClr val="E2E8F0"/>
+                </a:solidFill>
+                <a:latin typeface="Segoe UI"/>
+              </a:defRPr>
+            </a:pPr>
+            <a:r>
+              <a:t>• Session Revocation: Link is marked 410 Gone; cannot be accessed again.</a:t>
+            </a:r>
+          </a:p>
+          <a:p>
+            <a:pPr>
+              <a:spcBef>
+                <a:spcPts val="600"/>
+              </a:spcBef>
+              <a:defRPr sz="1100">
+                <a:solidFill>
+                  <a:srgbClr val="E2E8F0"/>
+                </a:solidFill>
+                <a:latin typeface="Segoe UI"/>
+              </a:defRPr>
+            </a:pPr>
+            <a:r>
+              <a:t>• Zero-Residual Privacy: No logs or leftover files remain on the server.</a:t>
+            </a:r>
+          </a:p>
+          <a:p>
+            <a:pPr>
+              <a:spcBef>
+                <a:spcPts val="600"/>
+              </a:spcBef>
+              <a:defRPr sz="1100">
+                <a:solidFill>
+                  <a:srgbClr val="E2E8F0"/>
+                </a:solidFill>
+                <a:latin typeface="Segoe UI"/>
+              </a:defRPr>
+            </a:pPr>
+            <a:r>
+              <a:t>• Protection Against Accidental Shares: Revoke files before recipients see them.</a:t>
             </a:r>
           </a:p>
         </p:txBody>
@@ -4711,7 +4321,7 @@
               </a:defRPr>
             </a:pPr>
             <a:r>
-              <a:t>PRODUCTION VERIFICATION</a:t>
+              <a:t>AUDIT &amp; ACTIVITY</a:t>
             </a:r>
           </a:p>
         </p:txBody>
@@ -4747,7 +4357,7 @@
               </a:defRPr>
             </a:pPr>
             <a:r>
-              <a:t>Automated Testing &amp; Live Deployment Proof</a:t>
+              <a:t>Transfer Activity Timeline &amp; Audit Logs</a:t>
             </a:r>
           </a:p>
           <a:p>
@@ -4763,21 +4373,45 @@
               </a:defRPr>
             </a:pPr>
             <a:r>
-              <a:t>Validated through comprehensive test suites and active cloud deployment.</a:t>
-            </a:r>
-          </a:p>
-        </p:txBody>
-      </p:sp>
-      <p:sp>
-        <p:nvSpPr>
-          <p:cNvPr id="5" name="Rounded Rectangle 4"/>
+              <a:t>Live application screenshot of the user activity timeline.</a:t>
+            </a:r>
+          </a:p>
+        </p:txBody>
+      </p:sp>
+      <p:pic>
+        <p:nvPicPr>
+          <p:cNvPr id="5" name="Picture 4" descr="screen_10_activity.png"/>
+          <p:cNvPicPr>
+            <a:picLocks noChangeAspect="1"/>
+          </p:cNvPicPr>
+          <p:nvPr/>
+        </p:nvPicPr>
+        <p:blipFill>
+          <a:blip r:embed="rId2"/>
+          <a:stretch>
+            <a:fillRect/>
+          </a:stretch>
+        </p:blipFill>
+        <p:spPr>
+          <a:xfrm>
+            <a:off x="731520" y="1645920"/>
+            <a:ext cx="6858000" cy="4572000"/>
+          </a:xfrm>
+          <a:prstGeom prst="rect">
+            <a:avLst/>
+          </a:prstGeom>
+        </p:spPr>
+      </p:pic>
+      <p:sp>
+        <p:nvSpPr>
+          <p:cNvPr id="6" name="Rounded Rectangle 5"/>
           <p:cNvSpPr/>
           <p:nvPr/>
         </p:nvSpPr>
         <p:spPr>
           <a:xfrm>
-            <a:off x="731520" y="1645920"/>
-            <a:ext cx="3383280" cy="4389120"/>
+            <a:off x="7863840" y="1645920"/>
+            <a:ext cx="3566160" cy="4572000"/>
           </a:xfrm>
           <a:prstGeom prst="roundRect">
             <a:avLst/>
@@ -4785,7 +4419,7 @@
           <a:solidFill>
             <a:srgbClr val="1E293B"/>
           </a:solidFill>
-          <a:ln>
+          <a:ln w="12700">
             <a:solidFill>
               <a:srgbClr val="334155"/>
             </a:solidFill>
@@ -4815,14 +4449,14 @@
       </p:sp>
       <p:sp>
         <p:nvSpPr>
-          <p:cNvPr id="6" name="TextBox 5"/>
+          <p:cNvPr id="7" name="TextBox 6"/>
           <p:cNvSpPr txBox="1"/>
           <p:nvPr/>
         </p:nvSpPr>
         <p:spPr>
           <a:xfrm>
-            <a:off x="960120" y="1828800"/>
-            <a:ext cx="2926080" cy="4023360"/>
+            <a:off x="8183880" y="1874519"/>
+            <a:ext cx="2926080" cy="4114800"/>
           </a:xfrm>
           <a:prstGeom prst="rect">
             <a:avLst/>
@@ -4836,364 +4470,7 @@
           <a:lstStyle/>
           <a:p>
             <a:pPr>
-              <a:defRPr sz="1300" b="1">
-                <a:solidFill>
-                  <a:srgbClr val="10B981"/>
-                </a:solidFill>
-                <a:latin typeface="Segoe UI"/>
-              </a:defRPr>
-            </a:pPr>
-            <a:r>
-              <a:t>Automated Test Coverage</a:t>
-            </a:r>
-          </a:p>
-          <a:p>
-            <a:pPr>
-              <a:spcBef>
-                <a:spcPts val="400"/>
-              </a:spcBef>
-              <a:defRPr sz="1100">
-                <a:solidFill>
-                  <a:srgbClr val="E2E8F0"/>
-                </a:solidFill>
-              </a:defRPr>
-            </a:pPr>
-            <a:r>
-              <a:t>• 53 / 53 Jest automated platform tests passing (100%).</a:t>
-            </a:r>
-          </a:p>
-          <a:p>
-            <a:pPr>
-              <a:spcBef>
-                <a:spcPts val="400"/>
-              </a:spcBef>
-              <a:defRPr sz="1100">
-                <a:solidFill>
-                  <a:srgbClr val="E2E8F0"/>
-                </a:solidFill>
-              </a:defRPr>
-            </a:pPr>
-            <a:r>
-              <a:t>• Authentication: Registration, bcrypt hashing, JWT issuance.</a:t>
-            </a:r>
-          </a:p>
-          <a:p>
-            <a:pPr>
-              <a:spcBef>
-                <a:spcPts val="400"/>
-              </a:spcBef>
-              <a:defRPr sz="1100">
-                <a:solidFill>
-                  <a:srgbClr val="E2E8F0"/>
-                </a:solidFill>
-              </a:defRPr>
-            </a:pPr>
-            <a:r>
-              <a:t>• Upload engine: File sanitization, SHA-256 hashes, size quotas.</a:t>
-            </a:r>
-          </a:p>
-          <a:p>
-            <a:pPr>
-              <a:spcBef>
-                <a:spcPts val="400"/>
-              </a:spcBef>
-              <a:defRPr sz="1100">
-                <a:solidFill>
-                  <a:srgbClr val="E2E8F0"/>
-                </a:solidFill>
-              </a:defRPr>
-            </a:pPr>
-            <a:r>
-              <a:t>• 6-Digit codes: Code lookup, rate limiting, and expiry lockout.</a:t>
-            </a:r>
-          </a:p>
-          <a:p>
-            <a:pPr>
-              <a:spcBef>
-                <a:spcPts val="400"/>
-              </a:spcBef>
-              <a:defRPr sz="1100">
-                <a:solidFill>
-                  <a:srgbClr val="E2E8F0"/>
-                </a:solidFill>
-              </a:defRPr>
-            </a:pPr>
-            <a:r>
-              <a:t>• Direct inboxes: Delivery checkmarks and view updates.</a:t>
-            </a:r>
-          </a:p>
-          <a:p>
-            <a:pPr>
-              <a:spcBef>
-                <a:spcPts val="400"/>
-              </a:spcBef>
-              <a:defRPr sz="1100">
-                <a:solidFill>
-                  <a:srgbClr val="E2E8F0"/>
-                </a:solidFill>
-              </a:defRPr>
-            </a:pPr>
-            <a:r>
-              <a:t>• File drive: Inline rename, trash soft-delete, and restore.</a:t>
-            </a:r>
-          </a:p>
-          <a:p>
-            <a:pPr>
-              <a:spcBef>
-                <a:spcPts val="400"/>
-              </a:spcBef>
-              <a:defRPr sz="1100">
-                <a:solidFill>
-                  <a:srgbClr val="E2E8F0"/>
-                </a:solidFill>
-              </a:defRPr>
-            </a:pPr>
-            <a:r>
-              <a:t>• Group collaboration: Chat messages, roles, and file deletion.</a:t>
-            </a:r>
-          </a:p>
-        </p:txBody>
-      </p:sp>
-      <p:sp>
-        <p:nvSpPr>
-          <p:cNvPr id="7" name="Rounded Rectangle 6"/>
-          <p:cNvSpPr/>
-          <p:nvPr/>
-        </p:nvSpPr>
-        <p:spPr>
-          <a:xfrm>
-            <a:off x="4389120" y="1645920"/>
-            <a:ext cx="3383280" cy="4389120"/>
-          </a:xfrm>
-          <a:prstGeom prst="roundRect">
-            <a:avLst/>
-          </a:prstGeom>
-          <a:solidFill>
-            <a:srgbClr val="1E293B"/>
-          </a:solidFill>
-          <a:ln>
-            <a:solidFill>
-              <a:srgbClr val="334155"/>
-            </a:solidFill>
-          </a:ln>
-        </p:spPr>
-        <p:style>
-          <a:lnRef idx="1">
-            <a:schemeClr val="accent1"/>
-          </a:lnRef>
-          <a:fillRef idx="3">
-            <a:schemeClr val="accent1"/>
-          </a:fillRef>
-          <a:effectRef idx="2">
-            <a:schemeClr val="accent1"/>
-          </a:effectRef>
-          <a:fontRef idx="minor">
-            <a:schemeClr val="lt1"/>
-          </a:fontRef>
-        </p:style>
-        <p:txBody>
-          <a:bodyPr rtlCol="0" anchor="ctr"/>
-          <a:lstStyle/>
-          <a:p>
-            <a:pPr algn="ctr"/>
-          </a:p>
-        </p:txBody>
-      </p:sp>
-      <p:sp>
-        <p:nvSpPr>
-          <p:cNvPr id="8" name="TextBox 7"/>
-          <p:cNvSpPr txBox="1"/>
-          <p:nvPr/>
-        </p:nvSpPr>
-        <p:spPr>
-          <a:xfrm>
-            <a:off x="4617720" y="1828800"/>
-            <a:ext cx="2926080" cy="4023360"/>
-          </a:xfrm>
-          <a:prstGeom prst="rect">
-            <a:avLst/>
-          </a:prstGeom>
-          <a:noFill/>
-        </p:spPr>
-        <p:txBody>
-          <a:bodyPr wrap="square">
-            <a:spAutoFit/>
-          </a:bodyPr>
-          <a:lstStyle/>
-          <a:p>
-            <a:pPr>
-              <a:defRPr sz="1300" b="1">
-                <a:solidFill>
-                  <a:srgbClr val="818CF8"/>
-                </a:solidFill>
-                <a:latin typeface="Segoe UI"/>
-              </a:defRPr>
-            </a:pPr>
-            <a:r>
-              <a:t>Security Verification</a:t>
-            </a:r>
-          </a:p>
-          <a:p>
-            <a:pPr>
-              <a:spcBef>
-                <a:spcPts val="400"/>
-              </a:spcBef>
-              <a:defRPr sz="1100">
-                <a:solidFill>
-                  <a:srgbClr val="E2E8F0"/>
-                </a:solidFill>
-              </a:defRPr>
-            </a:pPr>
-            <a:r>
-              <a:t>• High-entropy tokens: 128-bit share tokens (crypto.randomBytes).</a:t>
-            </a:r>
-          </a:p>
-          <a:p>
-            <a:pPr>
-              <a:spcBef>
-                <a:spcPts val="400"/>
-              </a:spcBef>
-              <a:defRPr sz="1100">
-                <a:solidFill>
-                  <a:srgbClr val="E2E8F0"/>
-                </a:solidFill>
-              </a:defRPr>
-            </a:pPr>
-            <a:r>
-              <a:t>• Owner secret key: 192-bit private token for physical purge.</a:t>
-            </a:r>
-          </a:p>
-          <a:p>
-            <a:pPr>
-              <a:spcBef>
-                <a:spcPts val="400"/>
-              </a:spcBef>
-              <a:defRPr sz="1100">
-                <a:solidFill>
-                  <a:srgbClr val="E2E8F0"/>
-                </a:solidFill>
-              </a:defRPr>
-            </a:pPr>
-            <a:r>
-              <a:t>• Immediate physical purge: Revocation returns HTTP 410 Gone.</a:t>
-            </a:r>
-          </a:p>
-          <a:p>
-            <a:pPr>
-              <a:spcBef>
-                <a:spcPts val="400"/>
-              </a:spcBef>
-              <a:defRPr sz="1100">
-                <a:solidFill>
-                  <a:srgbClr val="E2E8F0"/>
-                </a:solidFill>
-              </a:defRPr>
-            </a:pPr>
-            <a:r>
-              <a:t>• File blocklist: Blocks .exe, .bat, .sh, .vbs, .msi, and .php.</a:t>
-            </a:r>
-          </a:p>
-          <a:p>
-            <a:pPr>
-              <a:spcBef>
-                <a:spcPts val="400"/>
-              </a:spcBef>
-              <a:defRPr sz="1100">
-                <a:solidFill>
-                  <a:srgbClr val="E2E8F0"/>
-                </a:solidFill>
-              </a:defRPr>
-            </a:pPr>
-            <a:r>
-              <a:t>• Parameterized queries: 100% protection against SQL injection.</a:t>
-            </a:r>
-          </a:p>
-          <a:p>
-            <a:pPr>
-              <a:spcBef>
-                <a:spcPts val="400"/>
-              </a:spcBef>
-              <a:defRPr sz="1100">
-                <a:solidFill>
-                  <a:srgbClr val="E2E8F0"/>
-                </a:solidFill>
-              </a:defRPr>
-            </a:pPr>
-            <a:r>
-              <a:t>• Path traversal protection: Strict resolution against upload roots.</a:t>
-            </a:r>
-          </a:p>
-        </p:txBody>
-      </p:sp>
-      <p:sp>
-        <p:nvSpPr>
-          <p:cNvPr id="9" name="Rounded Rectangle 8"/>
-          <p:cNvSpPr/>
-          <p:nvPr/>
-        </p:nvSpPr>
-        <p:spPr>
-          <a:xfrm>
-            <a:off x="8046720" y="1645920"/>
-            <a:ext cx="3383280" cy="4389120"/>
-          </a:xfrm>
-          <a:prstGeom prst="roundRect">
-            <a:avLst/>
-          </a:prstGeom>
-          <a:solidFill>
-            <a:srgbClr val="1E293B"/>
-          </a:solidFill>
-          <a:ln>
-            <a:solidFill>
-              <a:srgbClr val="334155"/>
-            </a:solidFill>
-          </a:ln>
-        </p:spPr>
-        <p:style>
-          <a:lnRef idx="1">
-            <a:schemeClr val="accent1"/>
-          </a:lnRef>
-          <a:fillRef idx="3">
-            <a:schemeClr val="accent1"/>
-          </a:fillRef>
-          <a:effectRef idx="2">
-            <a:schemeClr val="accent1"/>
-          </a:effectRef>
-          <a:fontRef idx="minor">
-            <a:schemeClr val="lt1"/>
-          </a:fontRef>
-        </p:style>
-        <p:txBody>
-          <a:bodyPr rtlCol="0" anchor="ctr"/>
-          <a:lstStyle/>
-          <a:p>
-            <a:pPr algn="ctr"/>
-          </a:p>
-        </p:txBody>
-      </p:sp>
-      <p:sp>
-        <p:nvSpPr>
-          <p:cNvPr id="10" name="TextBox 9"/>
-          <p:cNvSpPr txBox="1"/>
-          <p:nvPr/>
-        </p:nvSpPr>
-        <p:spPr>
-          <a:xfrm>
-            <a:off x="8275320" y="1828800"/>
-            <a:ext cx="2926080" cy="4023360"/>
-          </a:xfrm>
-          <a:prstGeom prst="rect">
-            <a:avLst/>
-          </a:prstGeom>
-          <a:noFill/>
-        </p:spPr>
-        <p:txBody>
-          <a:bodyPr wrap="square">
-            <a:spAutoFit/>
-          </a:bodyPr>
-          <a:lstStyle/>
-          <a:p>
-            <a:pPr>
-              <a:defRPr sz="1300" b="1">
+              <a:defRPr sz="1400" b="1">
                 <a:solidFill>
                   <a:srgbClr val="F43F5E"/>
                 </a:solidFill>
@@ -5201,172 +4478,87 @@
               </a:defRPr>
             </a:pPr>
             <a:r>
-              <a:t>Live Production Links</a:t>
-            </a:r>
-          </a:p>
-          <a:p>
-            <a:pPr>
-              <a:spcBef>
-                <a:spcPts val="400"/>
-              </a:spcBef>
-              <a:defRPr sz="1100">
-                <a:solidFill>
-                  <a:srgbClr val="E2E8F0"/>
-                </a:solidFill>
-              </a:defRPr>
-            </a:pPr>
-            <a:r>
-              <a:t>• Frontend Web Application:</a:t>
-            </a:r>
-          </a:p>
-          <a:p>
-            <a:pPr>
-              <a:spcBef>
-                <a:spcPts val="400"/>
-              </a:spcBef>
-              <a:defRPr sz="1100">
-                <a:solidFill>
-                  <a:srgbClr val="E2E8F0"/>
-                </a:solidFill>
-              </a:defRPr>
-            </a:pPr>
-            <a:r>
-              <a:t>•   https://quickshare-nbkr.vercel.app/</a:t>
-            </a:r>
-          </a:p>
-          <a:p>
-            <a:pPr>
-              <a:spcBef>
-                <a:spcPts val="400"/>
-              </a:spcBef>
-              <a:defRPr sz="1100">
-                <a:solidFill>
-                  <a:srgbClr val="E2E8F0"/>
-                </a:solidFill>
-              </a:defRPr>
-            </a:pPr>
-            <a:r>
-              <a:t>• </a:t>
-            </a:r>
-          </a:p>
-          <a:p>
-            <a:pPr>
-              <a:spcBef>
-                <a:spcPts val="400"/>
-              </a:spcBef>
-              <a:defRPr sz="1100">
-                <a:solidFill>
-                  <a:srgbClr val="E2E8F0"/>
-                </a:solidFill>
-              </a:defRPr>
-            </a:pPr>
-            <a:r>
-              <a:t>• Backend REST API Service:</a:t>
-            </a:r>
-          </a:p>
-          <a:p>
-            <a:pPr>
-              <a:spcBef>
-                <a:spcPts val="400"/>
-              </a:spcBef>
-              <a:defRPr sz="1100">
-                <a:solidFill>
-                  <a:srgbClr val="E2E8F0"/>
-                </a:solidFill>
-              </a:defRPr>
-            </a:pPr>
-            <a:r>
-              <a:t>•   https://share-api-0xvn.onrender.com/api</a:t>
-            </a:r>
-          </a:p>
-          <a:p>
-            <a:pPr>
-              <a:spcBef>
-                <a:spcPts val="400"/>
-              </a:spcBef>
-              <a:defRPr sz="1100">
-                <a:solidFill>
-                  <a:srgbClr val="E2E8F0"/>
-                </a:solidFill>
-              </a:defRPr>
-            </a:pPr>
-            <a:r>
-              <a:t>• </a:t>
-            </a:r>
-          </a:p>
-          <a:p>
-            <a:pPr>
-              <a:spcBef>
-                <a:spcPts val="400"/>
-              </a:spcBef>
-              <a:defRPr sz="1100">
-                <a:solidFill>
-                  <a:srgbClr val="E2E8F0"/>
-                </a:solidFill>
-              </a:defRPr>
-            </a:pPr>
-            <a:r>
-              <a:t>• API Health Check:</a:t>
-            </a:r>
-          </a:p>
-          <a:p>
-            <a:pPr>
-              <a:spcBef>
-                <a:spcPts val="400"/>
-              </a:spcBef>
-              <a:defRPr sz="1100">
-                <a:solidFill>
-                  <a:srgbClr val="E2E8F0"/>
-                </a:solidFill>
-              </a:defRPr>
-            </a:pPr>
-            <a:r>
-              <a:t>•   https://share-api-0xvn.onrender.com/api/health</a:t>
-            </a:r>
-          </a:p>
-          <a:p>
-            <a:pPr>
-              <a:spcBef>
-                <a:spcPts val="400"/>
-              </a:spcBef>
-              <a:defRPr sz="1100">
-                <a:solidFill>
-                  <a:srgbClr val="E2E8F0"/>
-                </a:solidFill>
-              </a:defRPr>
-            </a:pPr>
-            <a:r>
-              <a:t>• </a:t>
-            </a:r>
-          </a:p>
-          <a:p>
-            <a:pPr>
-              <a:spcBef>
-                <a:spcPts val="400"/>
-              </a:spcBef>
-              <a:defRPr sz="1100">
-                <a:solidFill>
-                  <a:srgbClr val="E2E8F0"/>
-                </a:solidFill>
-              </a:defRPr>
-            </a:pPr>
-            <a:r>
-              <a:t>• GitHub Open-Source Repository:</a:t>
-            </a:r>
-          </a:p>
-          <a:p>
-            <a:pPr>
-              <a:spcBef>
-                <a:spcPts val="400"/>
-              </a:spcBef>
-              <a:defRPr sz="1100">
-                <a:solidFill>
-                  <a:srgbClr val="E2E8F0"/>
-                </a:solidFill>
-              </a:defRPr>
-            </a:pPr>
-            <a:r>
-              <a:t>•   https://github.com/sathidevivaraprasadreddy/share</a:t>
+              <a:t>Audit Trail &amp; Event Logging</a:t>
+            </a:r>
+          </a:p>
+          <a:p>
+            <a:pPr>
+              <a:spcBef>
+                <a:spcPts val="600"/>
+              </a:spcBef>
+              <a:defRPr sz="1100">
+                <a:solidFill>
+                  <a:srgbClr val="E2E8F0"/>
+                </a:solidFill>
+                <a:latin typeface="Segoe UI"/>
+              </a:defRPr>
+            </a:pPr>
+            <a:r>
+              <a:t>• Chronological Event Feed: Real-time logs for all file transfers.</a:t>
+            </a:r>
+          </a:p>
+          <a:p>
+            <a:pPr>
+              <a:spcBef>
+                <a:spcPts val="600"/>
+              </a:spcBef>
+              <a:defRPr sz="1100">
+                <a:solidFill>
+                  <a:srgbClr val="E2E8F0"/>
+                </a:solidFill>
+                <a:latin typeface="Segoe UI"/>
+              </a:defRPr>
+            </a:pPr>
+            <a:r>
+              <a:t>• Event Tracking: Logs file uploads, recipient inbox deliveries, and downloads.</a:t>
+            </a:r>
+          </a:p>
+          <a:p>
+            <a:pPr>
+              <a:spcBef>
+                <a:spcPts val="600"/>
+              </a:spcBef>
+              <a:defRPr sz="1100">
+                <a:solidFill>
+                  <a:srgbClr val="E2E8F0"/>
+                </a:solidFill>
+                <a:latin typeface="Segoe UI"/>
+              </a:defRPr>
+            </a:pPr>
+            <a:r>
+              <a:t>• Revocation Tracking: Confirms timestamp when an owner purges a file.</a:t>
+            </a:r>
+          </a:p>
+          <a:p>
+            <a:pPr>
+              <a:spcBef>
+                <a:spcPts val="600"/>
+              </a:spcBef>
+              <a:defRPr sz="1100">
+                <a:solidFill>
+                  <a:srgbClr val="E2E8F0"/>
+                </a:solidFill>
+                <a:latin typeface="Segoe UI"/>
+              </a:defRPr>
+            </a:pPr>
+            <a:r>
+              <a:t>• Privacy Protection: Users can clear their audit history with 1 click.</a:t>
+            </a:r>
+          </a:p>
+          <a:p>
+            <a:pPr>
+              <a:spcBef>
+                <a:spcPts val="600"/>
+              </a:spcBef>
+              <a:defRPr sz="1100">
+                <a:solidFill>
+                  <a:srgbClr val="E2E8F0"/>
+                </a:solidFill>
+                <a:latin typeface="Segoe UI"/>
+              </a:defRPr>
+            </a:pPr>
+            <a:r>
+              <a:t>• Zero Layout Shift: Smooth responsive layout on desktop and mobile viewports.</a:t>
             </a:r>
           </a:p>
         </p:txBody>
@@ -5432,6 +4624,2202 @@
           </a:p>
         </p:txBody>
       </p:sp>
+      <p:sp>
+        <p:nvSpPr>
+          <p:cNvPr id="3" name="TextBox 2"/>
+          <p:cNvSpPr txBox="1"/>
+          <p:nvPr/>
+        </p:nvSpPr>
+        <p:spPr>
+          <a:xfrm>
+            <a:off x="731520" y="365760"/>
+            <a:ext cx="10515600" cy="320040"/>
+          </a:xfrm>
+          <a:prstGeom prst="rect">
+            <a:avLst/>
+          </a:prstGeom>
+          <a:noFill/>
+        </p:spPr>
+        <p:txBody>
+          <a:bodyPr wrap="square">
+            <a:spAutoFit/>
+          </a:bodyPr>
+          <a:lstStyle/>
+          <a:p>
+            <a:pPr>
+              <a:defRPr sz="1100" b="1">
+                <a:solidFill>
+                  <a:srgbClr val="F43F5E"/>
+                </a:solidFill>
+                <a:latin typeface="Segoe UI"/>
+              </a:defRPr>
+            </a:pPr>
+            <a:r>
+              <a:t>MOBILE RESPONSIVENESS</a:t>
+            </a:r>
+          </a:p>
+        </p:txBody>
+      </p:sp>
+      <p:sp>
+        <p:nvSpPr>
+          <p:cNvPr id="4" name="TextBox 3"/>
+          <p:cNvSpPr txBox="1"/>
+          <p:nvPr/>
+        </p:nvSpPr>
+        <p:spPr>
+          <a:xfrm>
+            <a:off x="731520" y="658368"/>
+            <a:ext cx="10515600" cy="594360"/>
+          </a:xfrm>
+          <a:prstGeom prst="rect">
+            <a:avLst/>
+          </a:prstGeom>
+          <a:noFill/>
+        </p:spPr>
+        <p:txBody>
+          <a:bodyPr wrap="square">
+            <a:spAutoFit/>
+          </a:bodyPr>
+          <a:lstStyle/>
+          <a:p>
+            <a:pPr>
+              <a:defRPr sz="2200" b="1">
+                <a:solidFill>
+                  <a:srgbClr val="FFFFFF"/>
+                </a:solidFill>
+                <a:latin typeface="Segoe UI"/>
+              </a:defRPr>
+            </a:pPr>
+            <a:r>
+              <a:t>Mobile Design &amp; Docked Bottom Navigation</a:t>
+            </a:r>
+          </a:p>
+          <a:p>
+            <a:pPr>
+              <a:spcBef>
+                <a:spcPts val="300"/>
+              </a:spcBef>
+              <a:defRPr sz="1200">
+                <a:solidFill>
+                  <a:srgbClr val="94A3B8"/>
+                </a:solidFill>
+                <a:latin typeface="Segoe UI"/>
+              </a:defRPr>
+            </a:pPr>
+            <a:r>
+              <a:t>Live mobile screenshot captured on modern smartphone viewport (390 x 844).</a:t>
+            </a:r>
+          </a:p>
+        </p:txBody>
+      </p:sp>
+      <p:pic>
+        <p:nvPicPr>
+          <p:cNvPr id="5" name="Picture 4" descr="screen_11_mobile_bottom_nav.png"/>
+          <p:cNvPicPr>
+            <a:picLocks noChangeAspect="1"/>
+          </p:cNvPicPr>
+          <p:nvPr/>
+        </p:nvPicPr>
+        <p:blipFill>
+          <a:blip r:embed="rId2"/>
+          <a:stretch>
+            <a:fillRect/>
+          </a:stretch>
+        </p:blipFill>
+        <p:spPr>
+          <a:xfrm>
+            <a:off x="731520" y="1645920"/>
+            <a:ext cx="3108960" cy="4572000"/>
+          </a:xfrm>
+          <a:prstGeom prst="rect">
+            <a:avLst/>
+          </a:prstGeom>
+        </p:spPr>
+      </p:pic>
+      <p:sp>
+        <p:nvSpPr>
+          <p:cNvPr id="6" name="Rounded Rectangle 5"/>
+          <p:cNvSpPr/>
+          <p:nvPr/>
+        </p:nvSpPr>
+        <p:spPr>
+          <a:xfrm>
+            <a:off x="4114800" y="1645920"/>
+            <a:ext cx="7315200" cy="4572000"/>
+          </a:xfrm>
+          <a:prstGeom prst="roundRect">
+            <a:avLst/>
+          </a:prstGeom>
+          <a:solidFill>
+            <a:srgbClr val="1E293B"/>
+          </a:solidFill>
+          <a:ln w="12700">
+            <a:solidFill>
+              <a:srgbClr val="334155"/>
+            </a:solidFill>
+          </a:ln>
+        </p:spPr>
+        <p:style>
+          <a:lnRef idx="1">
+            <a:schemeClr val="accent1"/>
+          </a:lnRef>
+          <a:fillRef idx="3">
+            <a:schemeClr val="accent1"/>
+          </a:fillRef>
+          <a:effectRef idx="2">
+            <a:schemeClr val="accent1"/>
+          </a:effectRef>
+          <a:fontRef idx="minor">
+            <a:schemeClr val="lt1"/>
+          </a:fontRef>
+        </p:style>
+        <p:txBody>
+          <a:bodyPr rtlCol="0" anchor="ctr"/>
+          <a:lstStyle/>
+          <a:p>
+            <a:pPr algn="ctr"/>
+          </a:p>
+        </p:txBody>
+      </p:sp>
+      <p:sp>
+        <p:nvSpPr>
+          <p:cNvPr id="7" name="TextBox 6"/>
+          <p:cNvSpPr txBox="1"/>
+          <p:nvPr/>
+        </p:nvSpPr>
+        <p:spPr>
+          <a:xfrm>
+            <a:off x="4434840" y="1874519"/>
+            <a:ext cx="6675120" cy="4114800"/>
+          </a:xfrm>
+          <a:prstGeom prst="rect">
+            <a:avLst/>
+          </a:prstGeom>
+          <a:noFill/>
+        </p:spPr>
+        <p:txBody>
+          <a:bodyPr wrap="square">
+            <a:spAutoFit/>
+          </a:bodyPr>
+          <a:lstStyle/>
+          <a:p>
+            <a:pPr>
+              <a:defRPr sz="1400" b="1">
+                <a:solidFill>
+                  <a:srgbClr val="F43F5E"/>
+                </a:solidFill>
+                <a:latin typeface="Segoe UI"/>
+              </a:defRPr>
+            </a:pPr>
+            <a:r>
+              <a:t>Mobile Ergonomics &amp; Responsive Polish</a:t>
+            </a:r>
+          </a:p>
+          <a:p>
+            <a:pPr>
+              <a:spcBef>
+                <a:spcPts val="600"/>
+              </a:spcBef>
+              <a:defRPr sz="1100">
+                <a:solidFill>
+                  <a:srgbClr val="E2E8F0"/>
+                </a:solidFill>
+                <a:latin typeface="Segoe UI"/>
+              </a:defRPr>
+            </a:pPr>
+            <a:r>
+              <a:t>• Docked bottom navigation bar: Thumb-friendly reach for all primary tabs.</a:t>
+            </a:r>
+          </a:p>
+          <a:p>
+            <a:pPr>
+              <a:spcBef>
+                <a:spcPts val="600"/>
+              </a:spcBef>
+              <a:defRPr sz="1100">
+                <a:solidFill>
+                  <a:srgbClr val="E2E8F0"/>
+                </a:solidFill>
+                <a:latin typeface="Segoe UI"/>
+              </a:defRPr>
+            </a:pPr>
+            <a:r>
+              <a:t>• Instant navigation between Transfer, Inbox, My Files, Groups, and Activity.</a:t>
+            </a:r>
+          </a:p>
+          <a:p>
+            <a:pPr>
+              <a:spcBef>
+                <a:spcPts val="600"/>
+              </a:spcBef>
+              <a:defRPr sz="1100">
+                <a:solidFill>
+                  <a:srgbClr val="E2E8F0"/>
+                </a:solidFill>
+                <a:latin typeface="Segoe UI"/>
+              </a:defRPr>
+            </a:pPr>
+            <a:r>
+              <a:t>• Live badge notification: Displays unread transfer count on the Inbox icon.</a:t>
+            </a:r>
+          </a:p>
+          <a:p>
+            <a:pPr>
+              <a:spcBef>
+                <a:spcPts val="600"/>
+              </a:spcBef>
+              <a:defRPr sz="1100">
+                <a:solidFill>
+                  <a:srgbClr val="E2E8F0"/>
+                </a:solidFill>
+                <a:latin typeface="Segoe UI"/>
+              </a:defRPr>
+            </a:pPr>
+            <a:r>
+              <a:t>• Zero-clipping layout: Guaranteed full visibility on narrow 320px–420px screens.</a:t>
+            </a:r>
+          </a:p>
+          <a:p>
+            <a:pPr>
+              <a:spcBef>
+                <a:spcPts val="600"/>
+              </a:spcBef>
+              <a:defRPr sz="1100">
+                <a:solidFill>
+                  <a:srgbClr val="E2E8F0"/>
+                </a:solidFill>
+                <a:latin typeface="Segoe UI"/>
+              </a:defRPr>
+            </a:pPr>
+            <a:r>
+              <a:t>• Touch-optimized buttons: Clean touch targets prevent accidental clicks.</a:t>
+            </a:r>
+          </a:p>
+          <a:p>
+            <a:pPr>
+              <a:spcBef>
+                <a:spcPts val="600"/>
+              </a:spcBef>
+              <a:defRPr sz="1100">
+                <a:solidFill>
+                  <a:srgbClr val="E2E8F0"/>
+                </a:solidFill>
+                <a:latin typeface="Segoe UI"/>
+              </a:defRPr>
+            </a:pPr>
+            <a:r>
+              <a:t>• No layout shift: Smooth, instant transitions between desktop and mobile.</a:t>
+            </a:r>
+          </a:p>
+        </p:txBody>
+      </p:sp>
+    </p:spTree>
+  </p:cSld>
+  <p:clrMapOvr>
+    <a:masterClrMapping/>
+  </p:clrMapOvr>
+</p:sld>
+</file>
+
+<file path=ppt/slides/slide14.xml><?xml version="1.0" encoding="utf-8"?>
+<p:sld xmlns:a="http://schemas.openxmlformats.org/drawingml/2006/main" xmlns:p="http://schemas.openxmlformats.org/presentationml/2006/main" xmlns:r="http://schemas.openxmlformats.org/officeDocument/2006/relationships">
+  <p:cSld>
+    <p:spTree>
+      <p:nvGrpSpPr>
+        <p:cNvPr id="1" name=""/>
+        <p:cNvGrpSpPr/>
+        <p:nvPr/>
+      </p:nvGrpSpPr>
+      <p:grpSpPr/>
+      <p:sp>
+        <p:nvSpPr>
+          <p:cNvPr id="2" name="Rectangle 1"/>
+          <p:cNvSpPr/>
+          <p:nvPr/>
+        </p:nvSpPr>
+        <p:spPr>
+          <a:xfrm>
+            <a:off x="0" y="0"/>
+            <a:ext cx="12191695" cy="6858000"/>
+          </a:xfrm>
+          <a:prstGeom prst="rect">
+            <a:avLst/>
+          </a:prstGeom>
+          <a:solidFill>
+            <a:srgbClr val="0F172A"/>
+          </a:solidFill>
+          <a:ln>
+            <a:noFill/>
+          </a:ln>
+        </p:spPr>
+        <p:style>
+          <a:lnRef idx="1">
+            <a:schemeClr val="accent1"/>
+          </a:lnRef>
+          <a:fillRef idx="3">
+            <a:schemeClr val="accent1"/>
+          </a:fillRef>
+          <a:effectRef idx="2">
+            <a:schemeClr val="accent1"/>
+          </a:effectRef>
+          <a:fontRef idx="minor">
+            <a:schemeClr val="lt1"/>
+          </a:fontRef>
+        </p:style>
+        <p:txBody>
+          <a:bodyPr rtlCol="0" anchor="ctr"/>
+          <a:lstStyle/>
+          <a:p>
+            <a:pPr algn="ctr"/>
+          </a:p>
+        </p:txBody>
+      </p:sp>
+      <p:sp>
+        <p:nvSpPr>
+          <p:cNvPr id="3" name="TextBox 2"/>
+          <p:cNvSpPr txBox="1"/>
+          <p:nvPr/>
+        </p:nvSpPr>
+        <p:spPr>
+          <a:xfrm>
+            <a:off x="731520" y="365760"/>
+            <a:ext cx="10515600" cy="320040"/>
+          </a:xfrm>
+          <a:prstGeom prst="rect">
+            <a:avLst/>
+          </a:prstGeom>
+          <a:noFill/>
+        </p:spPr>
+        <p:txBody>
+          <a:bodyPr wrap="square">
+            <a:spAutoFit/>
+          </a:bodyPr>
+          <a:lstStyle/>
+          <a:p>
+            <a:pPr>
+              <a:defRPr sz="1100" b="1">
+                <a:solidFill>
+                  <a:srgbClr val="F43F5E"/>
+                </a:solidFill>
+                <a:latin typeface="Segoe UI"/>
+              </a:defRPr>
+            </a:pPr>
+            <a:r>
+              <a:t>VISUAL DESIGN</a:t>
+            </a:r>
+          </a:p>
+        </p:txBody>
+      </p:sp>
+      <p:sp>
+        <p:nvSpPr>
+          <p:cNvPr id="4" name="TextBox 3"/>
+          <p:cNvSpPr txBox="1"/>
+          <p:nvPr/>
+        </p:nvSpPr>
+        <p:spPr>
+          <a:xfrm>
+            <a:off x="731520" y="658368"/>
+            <a:ext cx="10515600" cy="594360"/>
+          </a:xfrm>
+          <a:prstGeom prst="rect">
+            <a:avLst/>
+          </a:prstGeom>
+          <a:noFill/>
+        </p:spPr>
+        <p:txBody>
+          <a:bodyPr wrap="square">
+            <a:spAutoFit/>
+          </a:bodyPr>
+          <a:lstStyle/>
+          <a:p>
+            <a:pPr>
+              <a:defRPr sz="2200" b="1">
+                <a:solidFill>
+                  <a:srgbClr val="FFFFFF"/>
+                </a:solidFill>
+                <a:latin typeface="Segoe UI"/>
+              </a:defRPr>
+            </a:pPr>
+            <a:r>
+              <a:t>Night Mode &amp; Visual Accessibility</a:t>
+            </a:r>
+          </a:p>
+          <a:p>
+            <a:pPr>
+              <a:spcBef>
+                <a:spcPts val="300"/>
+              </a:spcBef>
+              <a:defRPr sz="1200">
+                <a:solidFill>
+                  <a:srgbClr val="94A3B8"/>
+                </a:solidFill>
+                <a:latin typeface="Segoe UI"/>
+              </a:defRPr>
+            </a:pPr>
+            <a:r>
+              <a:t>Live application screenshot showing the high-contrast dark theme.</a:t>
+            </a:r>
+          </a:p>
+        </p:txBody>
+      </p:sp>
+      <p:pic>
+        <p:nvPicPr>
+          <p:cNvPr id="5" name="Picture 4" descr="screen_12_night_mode.png"/>
+          <p:cNvPicPr>
+            <a:picLocks noChangeAspect="1"/>
+          </p:cNvPicPr>
+          <p:nvPr/>
+        </p:nvPicPr>
+        <p:blipFill>
+          <a:blip r:embed="rId2"/>
+          <a:stretch>
+            <a:fillRect/>
+          </a:stretch>
+        </p:blipFill>
+        <p:spPr>
+          <a:xfrm>
+            <a:off x="731520" y="1645920"/>
+            <a:ext cx="6858000" cy="4572000"/>
+          </a:xfrm>
+          <a:prstGeom prst="rect">
+            <a:avLst/>
+          </a:prstGeom>
+        </p:spPr>
+      </p:pic>
+      <p:sp>
+        <p:nvSpPr>
+          <p:cNvPr id="6" name="Rounded Rectangle 5"/>
+          <p:cNvSpPr/>
+          <p:nvPr/>
+        </p:nvSpPr>
+        <p:spPr>
+          <a:xfrm>
+            <a:off x="7863840" y="1645920"/>
+            <a:ext cx="3566160" cy="4572000"/>
+          </a:xfrm>
+          <a:prstGeom prst="roundRect">
+            <a:avLst/>
+          </a:prstGeom>
+          <a:solidFill>
+            <a:srgbClr val="1E293B"/>
+          </a:solidFill>
+          <a:ln w="12700">
+            <a:solidFill>
+              <a:srgbClr val="334155"/>
+            </a:solidFill>
+          </a:ln>
+        </p:spPr>
+        <p:style>
+          <a:lnRef idx="1">
+            <a:schemeClr val="accent1"/>
+          </a:lnRef>
+          <a:fillRef idx="3">
+            <a:schemeClr val="accent1"/>
+          </a:fillRef>
+          <a:effectRef idx="2">
+            <a:schemeClr val="accent1"/>
+          </a:effectRef>
+          <a:fontRef idx="minor">
+            <a:schemeClr val="lt1"/>
+          </a:fontRef>
+        </p:style>
+        <p:txBody>
+          <a:bodyPr rtlCol="0" anchor="ctr"/>
+          <a:lstStyle/>
+          <a:p>
+            <a:pPr algn="ctr"/>
+          </a:p>
+        </p:txBody>
+      </p:sp>
+      <p:sp>
+        <p:nvSpPr>
+          <p:cNvPr id="7" name="TextBox 6"/>
+          <p:cNvSpPr txBox="1"/>
+          <p:nvPr/>
+        </p:nvSpPr>
+        <p:spPr>
+          <a:xfrm>
+            <a:off x="8183880" y="1874519"/>
+            <a:ext cx="2926080" cy="4114800"/>
+          </a:xfrm>
+          <a:prstGeom prst="rect">
+            <a:avLst/>
+          </a:prstGeom>
+          <a:noFill/>
+        </p:spPr>
+        <p:txBody>
+          <a:bodyPr wrap="square">
+            <a:spAutoFit/>
+          </a:bodyPr>
+          <a:lstStyle/>
+          <a:p>
+            <a:pPr>
+              <a:defRPr sz="1400" b="1">
+                <a:solidFill>
+                  <a:srgbClr val="F43F5E"/>
+                </a:solidFill>
+                <a:latin typeface="Segoe UI"/>
+              </a:defRPr>
+            </a:pPr>
+            <a:r>
+              <a:t>Visual Design &amp; Accessibility Features</a:t>
+            </a:r>
+          </a:p>
+          <a:p>
+            <a:pPr>
+              <a:spcBef>
+                <a:spcPts val="600"/>
+              </a:spcBef>
+              <a:defRPr sz="1100">
+                <a:solidFill>
+                  <a:srgbClr val="E2E8F0"/>
+                </a:solidFill>
+                <a:latin typeface="Segoe UI"/>
+              </a:defRPr>
+            </a:pPr>
+            <a:r>
+              <a:t>• Ambient radial canvas: Subtle depth mesh designed for extended use.</a:t>
+            </a:r>
+          </a:p>
+          <a:p>
+            <a:pPr>
+              <a:spcBef>
+                <a:spcPts val="600"/>
+              </a:spcBef>
+              <a:defRPr sz="1100">
+                <a:solidFill>
+                  <a:srgbClr val="E2E8F0"/>
+                </a:solidFill>
+                <a:latin typeface="Segoe UI"/>
+              </a:defRPr>
+            </a:pPr>
+            <a:r>
+              <a:t>• 1-Click theme toggle: Instant switch between Day (Light) and Night (Dark) mode.</a:t>
+            </a:r>
+          </a:p>
+          <a:p>
+            <a:pPr>
+              <a:spcBef>
+                <a:spcPts val="600"/>
+              </a:spcBef>
+              <a:defRPr sz="1100">
+                <a:solidFill>
+                  <a:srgbClr val="E2E8F0"/>
+                </a:solidFill>
+                <a:latin typeface="Segoe UI"/>
+              </a:defRPr>
+            </a:pPr>
+            <a:r>
+              <a:t>• Persistent user preference: Saved in browser local storage automatically.</a:t>
+            </a:r>
+          </a:p>
+          <a:p>
+            <a:pPr>
+              <a:spcBef>
+                <a:spcPts val="600"/>
+              </a:spcBef>
+              <a:defRPr sz="1100">
+                <a:solidFill>
+                  <a:srgbClr val="E2E8F0"/>
+                </a:solidFill>
+                <a:latin typeface="Segoe UI"/>
+              </a:defRPr>
+            </a:pPr>
+            <a:r>
+              <a:t>• WCAG-compliant contrast: High-contrast text ensures readable code displays.</a:t>
+            </a:r>
+          </a:p>
+          <a:p>
+            <a:pPr>
+              <a:spcBef>
+                <a:spcPts val="600"/>
+              </a:spcBef>
+              <a:defRPr sz="1100">
+                <a:solidFill>
+                  <a:srgbClr val="E2E8F0"/>
+                </a:solidFill>
+                <a:latin typeface="Segoe UI"/>
+              </a:defRPr>
+            </a:pPr>
+            <a:r>
+              <a:t>• Reduced eye strain: Optimal for evening study sessions and low-light labs.</a:t>
+            </a:r>
+          </a:p>
+          <a:p>
+            <a:pPr>
+              <a:spcBef>
+                <a:spcPts val="600"/>
+              </a:spcBef>
+              <a:defRPr sz="1100">
+                <a:solidFill>
+                  <a:srgbClr val="E2E8F0"/>
+                </a:solidFill>
+                <a:latin typeface="Segoe UI"/>
+              </a:defRPr>
+            </a:pPr>
+            <a:r>
+              <a:t>• Consistent UI language across all modals, drawers, and form controls.</a:t>
+            </a:r>
+          </a:p>
+        </p:txBody>
+      </p:sp>
+    </p:spTree>
+  </p:cSld>
+  <p:clrMapOvr>
+    <a:masterClrMapping/>
+  </p:clrMapOvr>
+</p:sld>
+</file>
+
+<file path=ppt/slides/slide15.xml><?xml version="1.0" encoding="utf-8"?>
+<p:sld xmlns:a="http://schemas.openxmlformats.org/drawingml/2006/main" xmlns:p="http://schemas.openxmlformats.org/presentationml/2006/main" xmlns:r="http://schemas.openxmlformats.org/officeDocument/2006/relationships">
+  <p:cSld>
+    <p:spTree>
+      <p:nvGrpSpPr>
+        <p:cNvPr id="1" name=""/>
+        <p:cNvGrpSpPr/>
+        <p:nvPr/>
+      </p:nvGrpSpPr>
+      <p:grpSpPr/>
+      <p:sp>
+        <p:nvSpPr>
+          <p:cNvPr id="2" name="Rectangle 1"/>
+          <p:cNvSpPr/>
+          <p:nvPr/>
+        </p:nvSpPr>
+        <p:spPr>
+          <a:xfrm>
+            <a:off x="0" y="0"/>
+            <a:ext cx="12191695" cy="6858000"/>
+          </a:xfrm>
+          <a:prstGeom prst="rect">
+            <a:avLst/>
+          </a:prstGeom>
+          <a:solidFill>
+            <a:srgbClr val="0F172A"/>
+          </a:solidFill>
+          <a:ln>
+            <a:noFill/>
+          </a:ln>
+        </p:spPr>
+        <p:style>
+          <a:lnRef idx="1">
+            <a:schemeClr val="accent1"/>
+          </a:lnRef>
+          <a:fillRef idx="3">
+            <a:schemeClr val="accent1"/>
+          </a:fillRef>
+          <a:effectRef idx="2">
+            <a:schemeClr val="accent1"/>
+          </a:effectRef>
+          <a:fontRef idx="minor">
+            <a:schemeClr val="lt1"/>
+          </a:fontRef>
+        </p:style>
+        <p:txBody>
+          <a:bodyPr rtlCol="0" anchor="ctr"/>
+          <a:lstStyle/>
+          <a:p>
+            <a:pPr algn="ctr"/>
+          </a:p>
+        </p:txBody>
+      </p:sp>
+      <p:sp>
+        <p:nvSpPr>
+          <p:cNvPr id="3" name="TextBox 2"/>
+          <p:cNvSpPr txBox="1"/>
+          <p:nvPr/>
+        </p:nvSpPr>
+        <p:spPr>
+          <a:xfrm>
+            <a:off x="731520" y="365760"/>
+            <a:ext cx="10515600" cy="320040"/>
+          </a:xfrm>
+          <a:prstGeom prst="rect">
+            <a:avLst/>
+          </a:prstGeom>
+          <a:noFill/>
+        </p:spPr>
+        <p:txBody>
+          <a:bodyPr wrap="square">
+            <a:spAutoFit/>
+          </a:bodyPr>
+          <a:lstStyle/>
+          <a:p>
+            <a:pPr>
+              <a:defRPr sz="1100" b="1">
+                <a:solidFill>
+                  <a:srgbClr val="F43F5E"/>
+                </a:solidFill>
+                <a:latin typeface="Segoe UI"/>
+              </a:defRPr>
+            </a:pPr>
+            <a:r>
+              <a:t>ENGINEERING SPECIFICATIONS</a:t>
+            </a:r>
+          </a:p>
+        </p:txBody>
+      </p:sp>
+      <p:sp>
+        <p:nvSpPr>
+          <p:cNvPr id="4" name="TextBox 3"/>
+          <p:cNvSpPr txBox="1"/>
+          <p:nvPr/>
+        </p:nvSpPr>
+        <p:spPr>
+          <a:xfrm>
+            <a:off x="731520" y="658368"/>
+            <a:ext cx="10515600" cy="594360"/>
+          </a:xfrm>
+          <a:prstGeom prst="rect">
+            <a:avLst/>
+          </a:prstGeom>
+          <a:noFill/>
+        </p:spPr>
+        <p:txBody>
+          <a:bodyPr wrap="square">
+            <a:spAutoFit/>
+          </a:bodyPr>
+          <a:lstStyle/>
+          <a:p>
+            <a:pPr>
+              <a:defRPr sz="2200" b="1">
+                <a:solidFill>
+                  <a:srgbClr val="FFFFFF"/>
+                </a:solidFill>
+                <a:latin typeface="Segoe UI"/>
+              </a:defRPr>
+            </a:pPr>
+            <a:r>
+              <a:t>Technology Stack &amp; ₹0 Cloud Economics</a:t>
+            </a:r>
+          </a:p>
+          <a:p>
+            <a:pPr>
+              <a:spcBef>
+                <a:spcPts val="300"/>
+              </a:spcBef>
+              <a:defRPr sz="1200">
+                <a:solidFill>
+                  <a:srgbClr val="94A3B8"/>
+                </a:solidFill>
+                <a:latin typeface="Segoe UI"/>
+              </a:defRPr>
+            </a:pPr>
+            <a:r>
+              <a:t>Demonstrating modern architectural efficiency with zero financial overhead.</a:t>
+            </a:r>
+          </a:p>
+        </p:txBody>
+      </p:sp>
+      <p:sp>
+        <p:nvSpPr>
+          <p:cNvPr id="5" name="Rounded Rectangle 4"/>
+          <p:cNvSpPr/>
+          <p:nvPr/>
+        </p:nvSpPr>
+        <p:spPr>
+          <a:xfrm>
+            <a:off x="731520" y="1645920"/>
+            <a:ext cx="2011680" cy="4389120"/>
+          </a:xfrm>
+          <a:prstGeom prst="roundRect">
+            <a:avLst/>
+          </a:prstGeom>
+          <a:solidFill>
+            <a:srgbClr val="1E293B"/>
+          </a:solidFill>
+          <a:ln>
+            <a:solidFill>
+              <a:srgbClr val="334155"/>
+            </a:solidFill>
+          </a:ln>
+        </p:spPr>
+        <p:style>
+          <a:lnRef idx="1">
+            <a:schemeClr val="accent1"/>
+          </a:lnRef>
+          <a:fillRef idx="3">
+            <a:schemeClr val="accent1"/>
+          </a:fillRef>
+          <a:effectRef idx="2">
+            <a:schemeClr val="accent1"/>
+          </a:effectRef>
+          <a:fontRef idx="minor">
+            <a:schemeClr val="lt1"/>
+          </a:fontRef>
+        </p:style>
+        <p:txBody>
+          <a:bodyPr rtlCol="0" anchor="ctr"/>
+          <a:lstStyle/>
+          <a:p>
+            <a:pPr algn="ctr"/>
+          </a:p>
+        </p:txBody>
+      </p:sp>
+      <p:sp>
+        <p:nvSpPr>
+          <p:cNvPr id="6" name="TextBox 5"/>
+          <p:cNvSpPr txBox="1"/>
+          <p:nvPr/>
+        </p:nvSpPr>
+        <p:spPr>
+          <a:xfrm>
+            <a:off x="868680" y="1920240"/>
+            <a:ext cx="1737360" cy="3840480"/>
+          </a:xfrm>
+          <a:prstGeom prst="rect">
+            <a:avLst/>
+          </a:prstGeom>
+          <a:noFill/>
+        </p:spPr>
+        <p:txBody>
+          <a:bodyPr wrap="square">
+            <a:spAutoFit/>
+          </a:bodyPr>
+          <a:lstStyle/>
+          <a:p>
+            <a:pPr algn="ctr">
+              <a:defRPr sz="2600" b="1">
+                <a:solidFill>
+                  <a:srgbClr val="F43F5E"/>
+                </a:solidFill>
+                <a:latin typeface="Segoe UI"/>
+              </a:defRPr>
+            </a:pPr>
+            <a:r>
+              <a:t>₹0 / Month</a:t>
+            </a:r>
+          </a:p>
+          <a:p>
+            <a:pPr algn="ctr">
+              <a:spcBef>
+                <a:spcPts val="800"/>
+              </a:spcBef>
+              <a:defRPr sz="1200" b="1">
+                <a:solidFill>
+                  <a:srgbClr val="FFFFFF"/>
+                </a:solidFill>
+              </a:defRPr>
+            </a:pPr>
+            <a:r>
+              <a:t>Total Hosting Cost</a:t>
+            </a:r>
+          </a:p>
+          <a:p>
+            <a:pPr algn="ctr">
+              <a:spcBef>
+                <a:spcPts val="1400"/>
+              </a:spcBef>
+              <a:defRPr sz="1100">
+                <a:solidFill>
+                  <a:srgbClr val="94A3B8"/>
+                </a:solidFill>
+              </a:defRPr>
+            </a:pPr>
+            <a:r>
+              <a:t>100% Free Forever</a:t>
+            </a:r>
+            <a:br/>
+            <a:r>
+              <a:t>No credit card required</a:t>
+            </a:r>
+            <a:br/>
+            <a:r>
+              <a:t>Production-ready SLA</a:t>
+            </a:r>
+          </a:p>
+        </p:txBody>
+      </p:sp>
+      <p:sp>
+        <p:nvSpPr>
+          <p:cNvPr id="7" name="Rounded Rectangle 6"/>
+          <p:cNvSpPr/>
+          <p:nvPr/>
+        </p:nvSpPr>
+        <p:spPr>
+          <a:xfrm>
+            <a:off x="2907791" y="1645920"/>
+            <a:ext cx="2011680" cy="4389120"/>
+          </a:xfrm>
+          <a:prstGeom prst="roundRect">
+            <a:avLst/>
+          </a:prstGeom>
+          <a:solidFill>
+            <a:srgbClr val="1E293B"/>
+          </a:solidFill>
+          <a:ln>
+            <a:solidFill>
+              <a:srgbClr val="334155"/>
+            </a:solidFill>
+          </a:ln>
+        </p:spPr>
+        <p:style>
+          <a:lnRef idx="1">
+            <a:schemeClr val="accent1"/>
+          </a:lnRef>
+          <a:fillRef idx="3">
+            <a:schemeClr val="accent1"/>
+          </a:fillRef>
+          <a:effectRef idx="2">
+            <a:schemeClr val="accent1"/>
+          </a:effectRef>
+          <a:fontRef idx="minor">
+            <a:schemeClr val="lt1"/>
+          </a:fontRef>
+        </p:style>
+        <p:txBody>
+          <a:bodyPr rtlCol="0" anchor="ctr"/>
+          <a:lstStyle/>
+          <a:p>
+            <a:pPr algn="ctr"/>
+          </a:p>
+        </p:txBody>
+      </p:sp>
+      <p:sp>
+        <p:nvSpPr>
+          <p:cNvPr id="8" name="TextBox 7"/>
+          <p:cNvSpPr txBox="1"/>
+          <p:nvPr/>
+        </p:nvSpPr>
+        <p:spPr>
+          <a:xfrm>
+            <a:off x="3044951" y="1920240"/>
+            <a:ext cx="1737360" cy="3840480"/>
+          </a:xfrm>
+          <a:prstGeom prst="rect">
+            <a:avLst/>
+          </a:prstGeom>
+          <a:noFill/>
+        </p:spPr>
+        <p:txBody>
+          <a:bodyPr wrap="square">
+            <a:spAutoFit/>
+          </a:bodyPr>
+          <a:lstStyle/>
+          <a:p>
+            <a:pPr algn="ctr">
+              <a:defRPr sz="2600" b="1">
+                <a:solidFill>
+                  <a:srgbClr val="818CF8"/>
+                </a:solidFill>
+                <a:latin typeface="Segoe UI"/>
+              </a:defRPr>
+            </a:pPr>
+            <a:r>
+              <a:t>100 GB</a:t>
+            </a:r>
+          </a:p>
+          <a:p>
+            <a:pPr algn="ctr">
+              <a:spcBef>
+                <a:spcPts val="800"/>
+              </a:spcBef>
+              <a:defRPr sz="1200" b="1">
+                <a:solidFill>
+                  <a:srgbClr val="FFFFFF"/>
+                </a:solidFill>
+              </a:defRPr>
+            </a:pPr>
+            <a:r>
+              <a:t>Vercel Edge CDN</a:t>
+            </a:r>
+          </a:p>
+          <a:p>
+            <a:pPr algn="ctr">
+              <a:spcBef>
+                <a:spcPts val="1400"/>
+              </a:spcBef>
+              <a:defRPr sz="1100">
+                <a:solidFill>
+                  <a:srgbClr val="94A3B8"/>
+                </a:solidFill>
+              </a:defRPr>
+            </a:pPr>
+            <a:r>
+              <a:t>React 18 &amp; Vite SPA</a:t>
+            </a:r>
+            <a:br/>
+            <a:r>
+              <a:t>Global edge caching</a:t>
+            </a:r>
+            <a:br/>
+            <a:r>
+              <a:t>Automatic SSL &amp; CI/CD</a:t>
+            </a:r>
+          </a:p>
+        </p:txBody>
+      </p:sp>
+      <p:sp>
+        <p:nvSpPr>
+          <p:cNvPr id="9" name="Rounded Rectangle 8"/>
+          <p:cNvSpPr/>
+          <p:nvPr/>
+        </p:nvSpPr>
+        <p:spPr>
+          <a:xfrm>
+            <a:off x="5084064" y="1645920"/>
+            <a:ext cx="2011680" cy="4389120"/>
+          </a:xfrm>
+          <a:prstGeom prst="roundRect">
+            <a:avLst/>
+          </a:prstGeom>
+          <a:solidFill>
+            <a:srgbClr val="1E293B"/>
+          </a:solidFill>
+          <a:ln>
+            <a:solidFill>
+              <a:srgbClr val="334155"/>
+            </a:solidFill>
+          </a:ln>
+        </p:spPr>
+        <p:style>
+          <a:lnRef idx="1">
+            <a:schemeClr val="accent1"/>
+          </a:lnRef>
+          <a:fillRef idx="3">
+            <a:schemeClr val="accent1"/>
+          </a:fillRef>
+          <a:effectRef idx="2">
+            <a:schemeClr val="accent1"/>
+          </a:effectRef>
+          <a:fontRef idx="minor">
+            <a:schemeClr val="lt1"/>
+          </a:fontRef>
+        </p:style>
+        <p:txBody>
+          <a:bodyPr rtlCol="0" anchor="ctr"/>
+          <a:lstStyle/>
+          <a:p>
+            <a:pPr algn="ctr"/>
+          </a:p>
+        </p:txBody>
+      </p:sp>
+      <p:sp>
+        <p:nvSpPr>
+          <p:cNvPr id="10" name="TextBox 9"/>
+          <p:cNvSpPr txBox="1"/>
+          <p:nvPr/>
+        </p:nvSpPr>
+        <p:spPr>
+          <a:xfrm>
+            <a:off x="5221224" y="1920240"/>
+            <a:ext cx="1737360" cy="3840480"/>
+          </a:xfrm>
+          <a:prstGeom prst="rect">
+            <a:avLst/>
+          </a:prstGeom>
+          <a:noFill/>
+        </p:spPr>
+        <p:txBody>
+          <a:bodyPr wrap="square">
+            <a:spAutoFit/>
+          </a:bodyPr>
+          <a:lstStyle/>
+          <a:p>
+            <a:pPr algn="ctr">
+              <a:defRPr sz="2600" b="1">
+                <a:solidFill>
+                  <a:srgbClr val="10B981"/>
+                </a:solidFill>
+                <a:latin typeface="Segoe UI"/>
+              </a:defRPr>
+            </a:pPr>
+            <a:r>
+              <a:t>512 MB</a:t>
+            </a:r>
+          </a:p>
+          <a:p>
+            <a:pPr algn="ctr">
+              <a:spcBef>
+                <a:spcPts val="800"/>
+              </a:spcBef>
+              <a:defRPr sz="1200" b="1">
+                <a:solidFill>
+                  <a:srgbClr val="FFFFFF"/>
+                </a:solidFill>
+              </a:defRPr>
+            </a:pPr>
+            <a:r>
+              <a:t>Render API Service</a:t>
+            </a:r>
+          </a:p>
+          <a:p>
+            <a:pPr algn="ctr">
+              <a:spcBef>
+                <a:spcPts val="1400"/>
+              </a:spcBef>
+              <a:defRPr sz="1100">
+                <a:solidFill>
+                  <a:srgbClr val="94A3B8"/>
+                </a:solidFill>
+              </a:defRPr>
+            </a:pPr>
+            <a:r>
+              <a:t>Node.js 22+ &amp; Express</a:t>
+            </a:r>
+            <a:br/>
+            <a:r>
+              <a:t>REST API &amp; WebSockets</a:t>
+            </a:r>
+            <a:br/>
+            <a:r>
+              <a:t>750 free hours/month</a:t>
+            </a:r>
+          </a:p>
+        </p:txBody>
+      </p:sp>
+      <p:sp>
+        <p:nvSpPr>
+          <p:cNvPr id="11" name="Rounded Rectangle 10"/>
+          <p:cNvSpPr/>
+          <p:nvPr/>
+        </p:nvSpPr>
+        <p:spPr>
+          <a:xfrm>
+            <a:off x="7260336" y="1645920"/>
+            <a:ext cx="2011680" cy="4389120"/>
+          </a:xfrm>
+          <a:prstGeom prst="roundRect">
+            <a:avLst/>
+          </a:prstGeom>
+          <a:solidFill>
+            <a:srgbClr val="1E293B"/>
+          </a:solidFill>
+          <a:ln>
+            <a:solidFill>
+              <a:srgbClr val="334155"/>
+            </a:solidFill>
+          </a:ln>
+        </p:spPr>
+        <p:style>
+          <a:lnRef idx="1">
+            <a:schemeClr val="accent1"/>
+          </a:lnRef>
+          <a:fillRef idx="3">
+            <a:schemeClr val="accent1"/>
+          </a:fillRef>
+          <a:effectRef idx="2">
+            <a:schemeClr val="accent1"/>
+          </a:effectRef>
+          <a:fontRef idx="minor">
+            <a:schemeClr val="lt1"/>
+          </a:fontRef>
+        </p:style>
+        <p:txBody>
+          <a:bodyPr rtlCol="0" anchor="ctr"/>
+          <a:lstStyle/>
+          <a:p>
+            <a:pPr algn="ctr"/>
+          </a:p>
+        </p:txBody>
+      </p:sp>
+      <p:sp>
+        <p:nvSpPr>
+          <p:cNvPr id="12" name="TextBox 11"/>
+          <p:cNvSpPr txBox="1"/>
+          <p:nvPr/>
+        </p:nvSpPr>
+        <p:spPr>
+          <a:xfrm>
+            <a:off x="7397496" y="1920240"/>
+            <a:ext cx="1737360" cy="3840480"/>
+          </a:xfrm>
+          <a:prstGeom prst="rect">
+            <a:avLst/>
+          </a:prstGeom>
+          <a:noFill/>
+        </p:spPr>
+        <p:txBody>
+          <a:bodyPr wrap="square">
+            <a:spAutoFit/>
+          </a:bodyPr>
+          <a:lstStyle/>
+          <a:p>
+            <a:pPr algn="ctr">
+              <a:defRPr sz="2600" b="1">
+                <a:solidFill>
+                  <a:srgbClr val="F43F5E"/>
+                </a:solidFill>
+                <a:latin typeface="Segoe UI"/>
+              </a:defRPr>
+            </a:pPr>
+            <a:r>
+              <a:t>5 GB</a:t>
+            </a:r>
+          </a:p>
+          <a:p>
+            <a:pPr algn="ctr">
+              <a:spcBef>
+                <a:spcPts val="800"/>
+              </a:spcBef>
+              <a:defRPr sz="1200" b="1">
+                <a:solidFill>
+                  <a:srgbClr val="FFFFFF"/>
+                </a:solidFill>
+              </a:defRPr>
+            </a:pPr>
+            <a:r>
+              <a:t>TiDB Serverless</a:t>
+            </a:r>
+          </a:p>
+          <a:p>
+            <a:pPr algn="ctr">
+              <a:spcBef>
+                <a:spcPts val="1400"/>
+              </a:spcBef>
+              <a:defRPr sz="1100">
+                <a:solidFill>
+                  <a:srgbClr val="94A3B8"/>
+                </a:solidFill>
+              </a:defRPr>
+            </a:pPr>
+            <a:r>
+              <a:t>Cloud MySQL 8 engine</a:t>
+            </a:r>
+            <a:br/>
+            <a:r>
+              <a:t>50M Request Units/month</a:t>
+            </a:r>
+            <a:br/>
+            <a:r>
+              <a:t>Dual SQLite dev driver</a:t>
+            </a:r>
+          </a:p>
+        </p:txBody>
+      </p:sp>
+      <p:sp>
+        <p:nvSpPr>
+          <p:cNvPr id="13" name="Rounded Rectangle 12"/>
+          <p:cNvSpPr/>
+          <p:nvPr/>
+        </p:nvSpPr>
+        <p:spPr>
+          <a:xfrm>
+            <a:off x="9436608" y="1645920"/>
+            <a:ext cx="2011680" cy="4389120"/>
+          </a:xfrm>
+          <a:prstGeom prst="roundRect">
+            <a:avLst/>
+          </a:prstGeom>
+          <a:solidFill>
+            <a:srgbClr val="1E293B"/>
+          </a:solidFill>
+          <a:ln>
+            <a:solidFill>
+              <a:srgbClr val="334155"/>
+            </a:solidFill>
+          </a:ln>
+        </p:spPr>
+        <p:style>
+          <a:lnRef idx="1">
+            <a:schemeClr val="accent1"/>
+          </a:lnRef>
+          <a:fillRef idx="3">
+            <a:schemeClr val="accent1"/>
+          </a:fillRef>
+          <a:effectRef idx="2">
+            <a:schemeClr val="accent1"/>
+          </a:effectRef>
+          <a:fontRef idx="minor">
+            <a:schemeClr val="lt1"/>
+          </a:fontRef>
+        </p:style>
+        <p:txBody>
+          <a:bodyPr rtlCol="0" anchor="ctr"/>
+          <a:lstStyle/>
+          <a:p>
+            <a:pPr algn="ctr"/>
+          </a:p>
+        </p:txBody>
+      </p:sp>
+      <p:sp>
+        <p:nvSpPr>
+          <p:cNvPr id="14" name="TextBox 13"/>
+          <p:cNvSpPr txBox="1"/>
+          <p:nvPr/>
+        </p:nvSpPr>
+        <p:spPr>
+          <a:xfrm>
+            <a:off x="9573768" y="1920240"/>
+            <a:ext cx="1737360" cy="3840480"/>
+          </a:xfrm>
+          <a:prstGeom prst="rect">
+            <a:avLst/>
+          </a:prstGeom>
+          <a:noFill/>
+        </p:spPr>
+        <p:txBody>
+          <a:bodyPr wrap="square">
+            <a:spAutoFit/>
+          </a:bodyPr>
+          <a:lstStyle/>
+          <a:p>
+            <a:pPr algn="ctr">
+              <a:defRPr sz="2600" b="1">
+                <a:solidFill>
+                  <a:srgbClr val="818CF8"/>
+                </a:solidFill>
+                <a:latin typeface="Segoe UI"/>
+              </a:defRPr>
+            </a:pPr>
+            <a:r>
+              <a:t>1 GB</a:t>
+            </a:r>
+          </a:p>
+          <a:p>
+            <a:pPr algn="ctr">
+              <a:spcBef>
+                <a:spcPts val="800"/>
+              </a:spcBef>
+              <a:defRPr sz="1200" b="1">
+                <a:solidFill>
+                  <a:srgbClr val="FFFFFF"/>
+                </a:solidFill>
+              </a:defRPr>
+            </a:pPr>
+            <a:r>
+              <a:t>Supabase S3 Storage</a:t>
+            </a:r>
+          </a:p>
+          <a:p>
+            <a:pPr algn="ctr">
+              <a:spcBef>
+                <a:spcPts val="1400"/>
+              </a:spcBef>
+              <a:defRPr sz="1100">
+                <a:solidFill>
+                  <a:srgbClr val="94A3B8"/>
+                </a:solidFill>
+              </a:defRPr>
+            </a:pPr>
+            <a:r>
+              <a:t>S3-compatible bucket</a:t>
+            </a:r>
+            <a:br/>
+            <a:r>
+              <a:t>Streaming downloads</a:t>
+            </a:r>
+            <a:br/>
+            <a:r>
+              <a:t>Automated purge cron</a:t>
+            </a:r>
+          </a:p>
+        </p:txBody>
+      </p:sp>
+    </p:spTree>
+  </p:cSld>
+  <p:clrMapOvr>
+    <a:masterClrMapping/>
+  </p:clrMapOvr>
+</p:sld>
+</file>
+
+<file path=ppt/slides/slide16.xml><?xml version="1.0" encoding="utf-8"?>
+<p:sld xmlns:a="http://schemas.openxmlformats.org/drawingml/2006/main" xmlns:p="http://schemas.openxmlformats.org/presentationml/2006/main" xmlns:r="http://schemas.openxmlformats.org/officeDocument/2006/relationships">
+  <p:cSld>
+    <p:spTree>
+      <p:nvGrpSpPr>
+        <p:cNvPr id="1" name=""/>
+        <p:cNvGrpSpPr/>
+        <p:nvPr/>
+      </p:nvGrpSpPr>
+      <p:grpSpPr/>
+      <p:sp>
+        <p:nvSpPr>
+          <p:cNvPr id="2" name="Rectangle 1"/>
+          <p:cNvSpPr/>
+          <p:nvPr/>
+        </p:nvSpPr>
+        <p:spPr>
+          <a:xfrm>
+            <a:off x="0" y="0"/>
+            <a:ext cx="12191695" cy="6858000"/>
+          </a:xfrm>
+          <a:prstGeom prst="rect">
+            <a:avLst/>
+          </a:prstGeom>
+          <a:solidFill>
+            <a:srgbClr val="0F172A"/>
+          </a:solidFill>
+          <a:ln>
+            <a:noFill/>
+          </a:ln>
+        </p:spPr>
+        <p:style>
+          <a:lnRef idx="1">
+            <a:schemeClr val="accent1"/>
+          </a:lnRef>
+          <a:fillRef idx="3">
+            <a:schemeClr val="accent1"/>
+          </a:fillRef>
+          <a:effectRef idx="2">
+            <a:schemeClr val="accent1"/>
+          </a:effectRef>
+          <a:fontRef idx="minor">
+            <a:schemeClr val="lt1"/>
+          </a:fontRef>
+        </p:style>
+        <p:txBody>
+          <a:bodyPr rtlCol="0" anchor="ctr"/>
+          <a:lstStyle/>
+          <a:p>
+            <a:pPr algn="ctr"/>
+          </a:p>
+        </p:txBody>
+      </p:sp>
+      <p:sp>
+        <p:nvSpPr>
+          <p:cNvPr id="3" name="TextBox 2"/>
+          <p:cNvSpPr txBox="1"/>
+          <p:nvPr/>
+        </p:nvSpPr>
+        <p:spPr>
+          <a:xfrm>
+            <a:off x="731520" y="365760"/>
+            <a:ext cx="10515600" cy="320040"/>
+          </a:xfrm>
+          <a:prstGeom prst="rect">
+            <a:avLst/>
+          </a:prstGeom>
+          <a:noFill/>
+        </p:spPr>
+        <p:txBody>
+          <a:bodyPr wrap="square">
+            <a:spAutoFit/>
+          </a:bodyPr>
+          <a:lstStyle/>
+          <a:p>
+            <a:pPr>
+              <a:defRPr sz="1100" b="1">
+                <a:solidFill>
+                  <a:srgbClr val="F43F5E"/>
+                </a:solidFill>
+                <a:latin typeface="Segoe UI"/>
+              </a:defRPr>
+            </a:pPr>
+            <a:r>
+              <a:t>PRODUCTION VERIFICATION</a:t>
+            </a:r>
+          </a:p>
+        </p:txBody>
+      </p:sp>
+      <p:sp>
+        <p:nvSpPr>
+          <p:cNvPr id="4" name="TextBox 3"/>
+          <p:cNvSpPr txBox="1"/>
+          <p:nvPr/>
+        </p:nvSpPr>
+        <p:spPr>
+          <a:xfrm>
+            <a:off x="731520" y="658368"/>
+            <a:ext cx="10515600" cy="594360"/>
+          </a:xfrm>
+          <a:prstGeom prst="rect">
+            <a:avLst/>
+          </a:prstGeom>
+          <a:noFill/>
+        </p:spPr>
+        <p:txBody>
+          <a:bodyPr wrap="square">
+            <a:spAutoFit/>
+          </a:bodyPr>
+          <a:lstStyle/>
+          <a:p>
+            <a:pPr>
+              <a:defRPr sz="2200" b="1">
+                <a:solidFill>
+                  <a:srgbClr val="FFFFFF"/>
+                </a:solidFill>
+                <a:latin typeface="Segoe UI"/>
+              </a:defRPr>
+            </a:pPr>
+            <a:r>
+              <a:t>Automated Testing &amp; Live Deployment Proof</a:t>
+            </a:r>
+          </a:p>
+          <a:p>
+            <a:pPr>
+              <a:spcBef>
+                <a:spcPts val="300"/>
+              </a:spcBef>
+              <a:defRPr sz="1200">
+                <a:solidFill>
+                  <a:srgbClr val="94A3B8"/>
+                </a:solidFill>
+                <a:latin typeface="Segoe UI"/>
+              </a:defRPr>
+            </a:pPr>
+            <a:r>
+              <a:t>Validated through comprehensive test suites and active cloud deployment.</a:t>
+            </a:r>
+          </a:p>
+        </p:txBody>
+      </p:sp>
+      <p:sp>
+        <p:nvSpPr>
+          <p:cNvPr id="5" name="Rounded Rectangle 4"/>
+          <p:cNvSpPr/>
+          <p:nvPr/>
+        </p:nvSpPr>
+        <p:spPr>
+          <a:xfrm>
+            <a:off x="731520" y="1645920"/>
+            <a:ext cx="3383280" cy="4389120"/>
+          </a:xfrm>
+          <a:prstGeom prst="roundRect">
+            <a:avLst/>
+          </a:prstGeom>
+          <a:solidFill>
+            <a:srgbClr val="1E293B"/>
+          </a:solidFill>
+          <a:ln>
+            <a:solidFill>
+              <a:srgbClr val="334155"/>
+            </a:solidFill>
+          </a:ln>
+        </p:spPr>
+        <p:style>
+          <a:lnRef idx="1">
+            <a:schemeClr val="accent1"/>
+          </a:lnRef>
+          <a:fillRef idx="3">
+            <a:schemeClr val="accent1"/>
+          </a:fillRef>
+          <a:effectRef idx="2">
+            <a:schemeClr val="accent1"/>
+          </a:effectRef>
+          <a:fontRef idx="minor">
+            <a:schemeClr val="lt1"/>
+          </a:fontRef>
+        </p:style>
+        <p:txBody>
+          <a:bodyPr rtlCol="0" anchor="ctr"/>
+          <a:lstStyle/>
+          <a:p>
+            <a:pPr algn="ctr"/>
+          </a:p>
+        </p:txBody>
+      </p:sp>
+      <p:sp>
+        <p:nvSpPr>
+          <p:cNvPr id="6" name="TextBox 5"/>
+          <p:cNvSpPr txBox="1"/>
+          <p:nvPr/>
+        </p:nvSpPr>
+        <p:spPr>
+          <a:xfrm>
+            <a:off x="960120" y="1828800"/>
+            <a:ext cx="2926080" cy="4023360"/>
+          </a:xfrm>
+          <a:prstGeom prst="rect">
+            <a:avLst/>
+          </a:prstGeom>
+          <a:noFill/>
+        </p:spPr>
+        <p:txBody>
+          <a:bodyPr wrap="square">
+            <a:spAutoFit/>
+          </a:bodyPr>
+          <a:lstStyle/>
+          <a:p>
+            <a:pPr>
+              <a:defRPr sz="1300" b="1">
+                <a:solidFill>
+                  <a:srgbClr val="10B981"/>
+                </a:solidFill>
+                <a:latin typeface="Segoe UI"/>
+              </a:defRPr>
+            </a:pPr>
+            <a:r>
+              <a:t>Automated Test Coverage</a:t>
+            </a:r>
+          </a:p>
+          <a:p>
+            <a:pPr>
+              <a:spcBef>
+                <a:spcPts val="400"/>
+              </a:spcBef>
+              <a:defRPr sz="1100">
+                <a:solidFill>
+                  <a:srgbClr val="E2E8F0"/>
+                </a:solidFill>
+              </a:defRPr>
+            </a:pPr>
+            <a:r>
+              <a:t>• 53 / 53 Jest automated platform tests passing (100%).</a:t>
+            </a:r>
+          </a:p>
+          <a:p>
+            <a:pPr>
+              <a:spcBef>
+                <a:spcPts val="400"/>
+              </a:spcBef>
+              <a:defRPr sz="1100">
+                <a:solidFill>
+                  <a:srgbClr val="E2E8F0"/>
+                </a:solidFill>
+              </a:defRPr>
+            </a:pPr>
+            <a:r>
+              <a:t>• Authentication: Registration, bcrypt hashing, JWT issuance.</a:t>
+            </a:r>
+          </a:p>
+          <a:p>
+            <a:pPr>
+              <a:spcBef>
+                <a:spcPts val="400"/>
+              </a:spcBef>
+              <a:defRPr sz="1100">
+                <a:solidFill>
+                  <a:srgbClr val="E2E8F0"/>
+                </a:solidFill>
+              </a:defRPr>
+            </a:pPr>
+            <a:r>
+              <a:t>• Upload engine: File sanitization, SHA-256 hashes, size quotas.</a:t>
+            </a:r>
+          </a:p>
+          <a:p>
+            <a:pPr>
+              <a:spcBef>
+                <a:spcPts val="400"/>
+              </a:spcBef>
+              <a:defRPr sz="1100">
+                <a:solidFill>
+                  <a:srgbClr val="E2E8F0"/>
+                </a:solidFill>
+              </a:defRPr>
+            </a:pPr>
+            <a:r>
+              <a:t>• 6-Digit codes: Code lookup, rate limiting, and expiry lockout.</a:t>
+            </a:r>
+          </a:p>
+          <a:p>
+            <a:pPr>
+              <a:spcBef>
+                <a:spcPts val="400"/>
+              </a:spcBef>
+              <a:defRPr sz="1100">
+                <a:solidFill>
+                  <a:srgbClr val="E2E8F0"/>
+                </a:solidFill>
+              </a:defRPr>
+            </a:pPr>
+            <a:r>
+              <a:t>• Direct inboxes: Delivery checkmarks and view updates.</a:t>
+            </a:r>
+          </a:p>
+          <a:p>
+            <a:pPr>
+              <a:spcBef>
+                <a:spcPts val="400"/>
+              </a:spcBef>
+              <a:defRPr sz="1100">
+                <a:solidFill>
+                  <a:srgbClr val="E2E8F0"/>
+                </a:solidFill>
+              </a:defRPr>
+            </a:pPr>
+            <a:r>
+              <a:t>• File drive: Inline rename, trash soft-delete, and restore.</a:t>
+            </a:r>
+          </a:p>
+          <a:p>
+            <a:pPr>
+              <a:spcBef>
+                <a:spcPts val="400"/>
+              </a:spcBef>
+              <a:defRPr sz="1100">
+                <a:solidFill>
+                  <a:srgbClr val="E2E8F0"/>
+                </a:solidFill>
+              </a:defRPr>
+            </a:pPr>
+            <a:r>
+              <a:t>• Group collaboration: Chat messages, roles, and file deletion.</a:t>
+            </a:r>
+          </a:p>
+        </p:txBody>
+      </p:sp>
+      <p:sp>
+        <p:nvSpPr>
+          <p:cNvPr id="7" name="Rounded Rectangle 6"/>
+          <p:cNvSpPr/>
+          <p:nvPr/>
+        </p:nvSpPr>
+        <p:spPr>
+          <a:xfrm>
+            <a:off x="4389120" y="1645920"/>
+            <a:ext cx="3383280" cy="4389120"/>
+          </a:xfrm>
+          <a:prstGeom prst="roundRect">
+            <a:avLst/>
+          </a:prstGeom>
+          <a:solidFill>
+            <a:srgbClr val="1E293B"/>
+          </a:solidFill>
+          <a:ln>
+            <a:solidFill>
+              <a:srgbClr val="334155"/>
+            </a:solidFill>
+          </a:ln>
+        </p:spPr>
+        <p:style>
+          <a:lnRef idx="1">
+            <a:schemeClr val="accent1"/>
+          </a:lnRef>
+          <a:fillRef idx="3">
+            <a:schemeClr val="accent1"/>
+          </a:fillRef>
+          <a:effectRef idx="2">
+            <a:schemeClr val="accent1"/>
+          </a:effectRef>
+          <a:fontRef idx="minor">
+            <a:schemeClr val="lt1"/>
+          </a:fontRef>
+        </p:style>
+        <p:txBody>
+          <a:bodyPr rtlCol="0" anchor="ctr"/>
+          <a:lstStyle/>
+          <a:p>
+            <a:pPr algn="ctr"/>
+          </a:p>
+        </p:txBody>
+      </p:sp>
+      <p:sp>
+        <p:nvSpPr>
+          <p:cNvPr id="8" name="TextBox 7"/>
+          <p:cNvSpPr txBox="1"/>
+          <p:nvPr/>
+        </p:nvSpPr>
+        <p:spPr>
+          <a:xfrm>
+            <a:off x="4617720" y="1828800"/>
+            <a:ext cx="2926080" cy="4023360"/>
+          </a:xfrm>
+          <a:prstGeom prst="rect">
+            <a:avLst/>
+          </a:prstGeom>
+          <a:noFill/>
+        </p:spPr>
+        <p:txBody>
+          <a:bodyPr wrap="square">
+            <a:spAutoFit/>
+          </a:bodyPr>
+          <a:lstStyle/>
+          <a:p>
+            <a:pPr>
+              <a:defRPr sz="1300" b="1">
+                <a:solidFill>
+                  <a:srgbClr val="818CF8"/>
+                </a:solidFill>
+                <a:latin typeface="Segoe UI"/>
+              </a:defRPr>
+            </a:pPr>
+            <a:r>
+              <a:t>Security Verification</a:t>
+            </a:r>
+          </a:p>
+          <a:p>
+            <a:pPr>
+              <a:spcBef>
+                <a:spcPts val="400"/>
+              </a:spcBef>
+              <a:defRPr sz="1100">
+                <a:solidFill>
+                  <a:srgbClr val="E2E8F0"/>
+                </a:solidFill>
+              </a:defRPr>
+            </a:pPr>
+            <a:r>
+              <a:t>• High-entropy tokens: 128-bit share tokens (crypto.randomBytes).</a:t>
+            </a:r>
+          </a:p>
+          <a:p>
+            <a:pPr>
+              <a:spcBef>
+                <a:spcPts val="400"/>
+              </a:spcBef>
+              <a:defRPr sz="1100">
+                <a:solidFill>
+                  <a:srgbClr val="E2E8F0"/>
+                </a:solidFill>
+              </a:defRPr>
+            </a:pPr>
+            <a:r>
+              <a:t>• Owner secret key: 192-bit private token for physical purge.</a:t>
+            </a:r>
+          </a:p>
+          <a:p>
+            <a:pPr>
+              <a:spcBef>
+                <a:spcPts val="400"/>
+              </a:spcBef>
+              <a:defRPr sz="1100">
+                <a:solidFill>
+                  <a:srgbClr val="E2E8F0"/>
+                </a:solidFill>
+              </a:defRPr>
+            </a:pPr>
+            <a:r>
+              <a:t>• Immediate physical purge: Revocation returns HTTP 410 Gone.</a:t>
+            </a:r>
+          </a:p>
+          <a:p>
+            <a:pPr>
+              <a:spcBef>
+                <a:spcPts val="400"/>
+              </a:spcBef>
+              <a:defRPr sz="1100">
+                <a:solidFill>
+                  <a:srgbClr val="E2E8F0"/>
+                </a:solidFill>
+              </a:defRPr>
+            </a:pPr>
+            <a:r>
+              <a:t>• File blocklist: Blocks .exe, .bat, .sh, .vbs, .msi, and .php.</a:t>
+            </a:r>
+          </a:p>
+          <a:p>
+            <a:pPr>
+              <a:spcBef>
+                <a:spcPts val="400"/>
+              </a:spcBef>
+              <a:defRPr sz="1100">
+                <a:solidFill>
+                  <a:srgbClr val="E2E8F0"/>
+                </a:solidFill>
+              </a:defRPr>
+            </a:pPr>
+            <a:r>
+              <a:t>• Parameterized queries: 100% protection against SQL injection.</a:t>
+            </a:r>
+          </a:p>
+          <a:p>
+            <a:pPr>
+              <a:spcBef>
+                <a:spcPts val="400"/>
+              </a:spcBef>
+              <a:defRPr sz="1100">
+                <a:solidFill>
+                  <a:srgbClr val="E2E8F0"/>
+                </a:solidFill>
+              </a:defRPr>
+            </a:pPr>
+            <a:r>
+              <a:t>• Path traversal protection: Strict resolution against upload roots.</a:t>
+            </a:r>
+          </a:p>
+        </p:txBody>
+      </p:sp>
+      <p:sp>
+        <p:nvSpPr>
+          <p:cNvPr id="9" name="Rounded Rectangle 8"/>
+          <p:cNvSpPr/>
+          <p:nvPr/>
+        </p:nvSpPr>
+        <p:spPr>
+          <a:xfrm>
+            <a:off x="8046720" y="1645920"/>
+            <a:ext cx="3383280" cy="4389120"/>
+          </a:xfrm>
+          <a:prstGeom prst="roundRect">
+            <a:avLst/>
+          </a:prstGeom>
+          <a:solidFill>
+            <a:srgbClr val="1E293B"/>
+          </a:solidFill>
+          <a:ln>
+            <a:solidFill>
+              <a:srgbClr val="334155"/>
+            </a:solidFill>
+          </a:ln>
+        </p:spPr>
+        <p:style>
+          <a:lnRef idx="1">
+            <a:schemeClr val="accent1"/>
+          </a:lnRef>
+          <a:fillRef idx="3">
+            <a:schemeClr val="accent1"/>
+          </a:fillRef>
+          <a:effectRef idx="2">
+            <a:schemeClr val="accent1"/>
+          </a:effectRef>
+          <a:fontRef idx="minor">
+            <a:schemeClr val="lt1"/>
+          </a:fontRef>
+        </p:style>
+        <p:txBody>
+          <a:bodyPr rtlCol="0" anchor="ctr"/>
+          <a:lstStyle/>
+          <a:p>
+            <a:pPr algn="ctr"/>
+          </a:p>
+        </p:txBody>
+      </p:sp>
+      <p:sp>
+        <p:nvSpPr>
+          <p:cNvPr id="10" name="TextBox 9"/>
+          <p:cNvSpPr txBox="1"/>
+          <p:nvPr/>
+        </p:nvSpPr>
+        <p:spPr>
+          <a:xfrm>
+            <a:off x="8275320" y="1828800"/>
+            <a:ext cx="2926080" cy="4023360"/>
+          </a:xfrm>
+          <a:prstGeom prst="rect">
+            <a:avLst/>
+          </a:prstGeom>
+          <a:noFill/>
+        </p:spPr>
+        <p:txBody>
+          <a:bodyPr wrap="square">
+            <a:spAutoFit/>
+          </a:bodyPr>
+          <a:lstStyle/>
+          <a:p>
+            <a:pPr>
+              <a:defRPr sz="1300" b="1">
+                <a:solidFill>
+                  <a:srgbClr val="F43F5E"/>
+                </a:solidFill>
+                <a:latin typeface="Segoe UI"/>
+              </a:defRPr>
+            </a:pPr>
+            <a:r>
+              <a:t>Live Production Links</a:t>
+            </a:r>
+          </a:p>
+          <a:p>
+            <a:pPr>
+              <a:spcBef>
+                <a:spcPts val="400"/>
+              </a:spcBef>
+              <a:defRPr sz="1100">
+                <a:solidFill>
+                  <a:srgbClr val="E2E8F0"/>
+                </a:solidFill>
+              </a:defRPr>
+            </a:pPr>
+            <a:r>
+              <a:t>• Frontend Web Application:</a:t>
+            </a:r>
+          </a:p>
+          <a:p>
+            <a:pPr>
+              <a:spcBef>
+                <a:spcPts val="400"/>
+              </a:spcBef>
+              <a:defRPr sz="1100">
+                <a:solidFill>
+                  <a:srgbClr val="E2E8F0"/>
+                </a:solidFill>
+              </a:defRPr>
+            </a:pPr>
+            <a:r>
+              <a:t>•   https://quickshare-nbkr.vercel.app/</a:t>
+            </a:r>
+          </a:p>
+          <a:p>
+            <a:pPr>
+              <a:spcBef>
+                <a:spcPts val="400"/>
+              </a:spcBef>
+              <a:defRPr sz="1100">
+                <a:solidFill>
+                  <a:srgbClr val="E2E8F0"/>
+                </a:solidFill>
+              </a:defRPr>
+            </a:pPr>
+            <a:r>
+              <a:t>• </a:t>
+            </a:r>
+          </a:p>
+          <a:p>
+            <a:pPr>
+              <a:spcBef>
+                <a:spcPts val="400"/>
+              </a:spcBef>
+              <a:defRPr sz="1100">
+                <a:solidFill>
+                  <a:srgbClr val="E2E8F0"/>
+                </a:solidFill>
+              </a:defRPr>
+            </a:pPr>
+            <a:r>
+              <a:t>• Backend REST API Service:</a:t>
+            </a:r>
+          </a:p>
+          <a:p>
+            <a:pPr>
+              <a:spcBef>
+                <a:spcPts val="400"/>
+              </a:spcBef>
+              <a:defRPr sz="1100">
+                <a:solidFill>
+                  <a:srgbClr val="E2E8F0"/>
+                </a:solidFill>
+              </a:defRPr>
+            </a:pPr>
+            <a:r>
+              <a:t>•   https://share-api-0xvn.onrender.com/api</a:t>
+            </a:r>
+          </a:p>
+          <a:p>
+            <a:pPr>
+              <a:spcBef>
+                <a:spcPts val="400"/>
+              </a:spcBef>
+              <a:defRPr sz="1100">
+                <a:solidFill>
+                  <a:srgbClr val="E2E8F0"/>
+                </a:solidFill>
+              </a:defRPr>
+            </a:pPr>
+            <a:r>
+              <a:t>• </a:t>
+            </a:r>
+          </a:p>
+          <a:p>
+            <a:pPr>
+              <a:spcBef>
+                <a:spcPts val="400"/>
+              </a:spcBef>
+              <a:defRPr sz="1100">
+                <a:solidFill>
+                  <a:srgbClr val="E2E8F0"/>
+                </a:solidFill>
+              </a:defRPr>
+            </a:pPr>
+            <a:r>
+              <a:t>• API Health Check:</a:t>
+            </a:r>
+          </a:p>
+          <a:p>
+            <a:pPr>
+              <a:spcBef>
+                <a:spcPts val="400"/>
+              </a:spcBef>
+              <a:defRPr sz="1100">
+                <a:solidFill>
+                  <a:srgbClr val="E2E8F0"/>
+                </a:solidFill>
+              </a:defRPr>
+            </a:pPr>
+            <a:r>
+              <a:t>•   https://share-api-0xvn.onrender.com/api/health</a:t>
+            </a:r>
+          </a:p>
+          <a:p>
+            <a:pPr>
+              <a:spcBef>
+                <a:spcPts val="400"/>
+              </a:spcBef>
+              <a:defRPr sz="1100">
+                <a:solidFill>
+                  <a:srgbClr val="E2E8F0"/>
+                </a:solidFill>
+              </a:defRPr>
+            </a:pPr>
+            <a:r>
+              <a:t>• </a:t>
+            </a:r>
+          </a:p>
+          <a:p>
+            <a:pPr>
+              <a:spcBef>
+                <a:spcPts val="400"/>
+              </a:spcBef>
+              <a:defRPr sz="1100">
+                <a:solidFill>
+                  <a:srgbClr val="E2E8F0"/>
+                </a:solidFill>
+              </a:defRPr>
+            </a:pPr>
+            <a:r>
+              <a:t>• GitHub Open-Source Repository:</a:t>
+            </a:r>
+          </a:p>
+          <a:p>
+            <a:pPr>
+              <a:spcBef>
+                <a:spcPts val="400"/>
+              </a:spcBef>
+              <a:defRPr sz="1100">
+                <a:solidFill>
+                  <a:srgbClr val="E2E8F0"/>
+                </a:solidFill>
+              </a:defRPr>
+            </a:pPr>
+            <a:r>
+              <a:t>•   https://github.com/sathidevivaraprasadreddy/share</a:t>
+            </a:r>
+          </a:p>
+        </p:txBody>
+      </p:sp>
+    </p:spTree>
+  </p:cSld>
+  <p:clrMapOvr>
+    <a:masterClrMapping/>
+  </p:clrMapOvr>
+</p:sld>
+</file>
+
+<file path=ppt/slides/slide17.xml><?xml version="1.0" encoding="utf-8"?>
+<p:sld xmlns:a="http://schemas.openxmlformats.org/drawingml/2006/main" xmlns:p="http://schemas.openxmlformats.org/presentationml/2006/main" xmlns:r="http://schemas.openxmlformats.org/officeDocument/2006/relationships">
+  <p:cSld>
+    <p:spTree>
+      <p:nvGrpSpPr>
+        <p:cNvPr id="1" name=""/>
+        <p:cNvGrpSpPr/>
+        <p:nvPr/>
+      </p:nvGrpSpPr>
+      <p:grpSpPr/>
+      <p:sp>
+        <p:nvSpPr>
+          <p:cNvPr id="2" name="Rectangle 1"/>
+          <p:cNvSpPr/>
+          <p:nvPr/>
+        </p:nvSpPr>
+        <p:spPr>
+          <a:xfrm>
+            <a:off x="0" y="0"/>
+            <a:ext cx="12191695" cy="6858000"/>
+          </a:xfrm>
+          <a:prstGeom prst="rect">
+            <a:avLst/>
+          </a:prstGeom>
+          <a:solidFill>
+            <a:srgbClr val="0F172A"/>
+          </a:solidFill>
+          <a:ln>
+            <a:noFill/>
+          </a:ln>
+        </p:spPr>
+        <p:style>
+          <a:lnRef idx="1">
+            <a:schemeClr val="accent1"/>
+          </a:lnRef>
+          <a:fillRef idx="3">
+            <a:schemeClr val="accent1"/>
+          </a:fillRef>
+          <a:effectRef idx="2">
+            <a:schemeClr val="accent1"/>
+          </a:effectRef>
+          <a:fontRef idx="minor">
+            <a:schemeClr val="lt1"/>
+          </a:fontRef>
+        </p:style>
+        <p:txBody>
+          <a:bodyPr rtlCol="0" anchor="ctr"/>
+          <a:lstStyle/>
+          <a:p>
+            <a:pPr algn="ctr"/>
+          </a:p>
+        </p:txBody>
+      </p:sp>
       <p:pic>
         <p:nvPicPr>
           <p:cNvPr id="3" name="Picture 2" descr="slide_1_img_1.jpg"/>
@@ -7246,7 +8634,7 @@
               </a:defRPr>
             </a:pPr>
             <a:r>
-              <a:t>REAL APPLICATION INTERFACE</a:t>
+              <a:t>AUTHENTICATION SYSTEM</a:t>
             </a:r>
           </a:p>
         </p:txBody>
@@ -7282,7 +8670,7 @@
               </a:defRPr>
             </a:pPr>
             <a:r>
-              <a:t>Transfer Dashboard: Primary Send Interface</a:t>
+              <a:t>User Sign-In &amp; Registration Modal</a:t>
             </a:r>
           </a:p>
           <a:p>
@@ -7298,14 +8686,14 @@
               </a:defRPr>
             </a:pPr>
             <a:r>
-              <a:t>Live desktop screenshot of the QuickShare upload workspace.</a:t>
+              <a:t>Live application screenshot of the QuickShare authentication modal.</a:t>
             </a:r>
           </a:p>
         </p:txBody>
       </p:sp>
       <p:pic>
         <p:nvPicPr>
-          <p:cNvPr id="5" name="Picture 4" descr="01_transfer_dashboard.png"/>
+          <p:cNvPr id="5" name="Picture 4" descr="screen_01_auth_modal.png"/>
           <p:cNvPicPr>
             <a:picLocks noChangeAspect="1"/>
           </p:cNvPicPr>
@@ -7403,7 +8791,7 @@
               </a:defRPr>
             </a:pPr>
             <a:r>
-              <a:t>Send Functions &amp; Controls</a:t>
+              <a:t>Authentication Functions</a:t>
             </a:r>
           </a:p>
           <a:p>
@@ -7419,7 +8807,7 @@
               </a:defRPr>
             </a:pPr>
             <a:r>
-              <a:t>• Drag &amp; drop upload zone supporting up to 10 files simultaneously.</a:t>
+              <a:t>• Official Google OAuth 2.0: Instant 1-tap Google Sign-In with JWT verification.</a:t>
             </a:r>
           </a:p>
           <a:p>
@@ -7435,7 +8823,7 @@
               </a:defRPr>
             </a:pPr>
             <a:r>
-              <a:t>• File size presets (10 MB, 25 MB, 50 MB) and live upload progress tracking.</a:t>
+              <a:t>• Email &amp; Password Sign-In: Secure salted hashing with Bcrypt encryption.</a:t>
             </a:r>
           </a:p>
           <a:p>
@@ -7451,7 +8839,7 @@
               </a:defRPr>
             </a:pPr>
             <a:r>
-              <a:t>• Custom expiration timer: 1 Hour, 6 Hours, 24 Hours, 3 Days, or 7 Days.</a:t>
+              <a:t>• Free Account Registration: Users can register in seconds with zero fees.</a:t>
             </a:r>
           </a:p>
           <a:p>
@@ -7467,7 +8855,7 @@
               </a:defRPr>
             </a:pPr>
             <a:r>
-              <a:t>• Security settings: Optional password protection using Bcrypt encryption.</a:t>
+              <a:t>• Direct Email OTP: Dispatches 6-digit one-time verification codes via SMTP.</a:t>
             </a:r>
           </a:p>
           <a:p>
@@ -7483,7 +8871,7 @@
               </a:defRPr>
             </a:pPr>
             <a:r>
-              <a:t>• Burn-on-Download: Automatically deletes files after the first download.</a:t>
+              <a:t>• Session Security: Authenticates users with cryptographic JSON Web Tokens (JWT).</a:t>
             </a:r>
           </a:p>
           <a:p>
@@ -7499,7 +8887,7 @@
               </a:defRPr>
             </a:pPr>
             <a:r>
-              <a:t>• Direct Inbox delivery toggle: Dispatch straight to a classmate's account.</a:t>
+              <a:t>• Guest Compatibility: All basic transfers remain accessible without sign-in.</a:t>
             </a:r>
           </a:p>
         </p:txBody>
@@ -7596,7 +8984,7 @@
               </a:defRPr>
             </a:pPr>
             <a:r>
-              <a:t>REAL APPLICATION INTERFACE</a:t>
+              <a:t>TRANSFER WORKSPACE</a:t>
             </a:r>
           </a:p>
         </p:txBody>
@@ -7632,7 +9020,7 @@
               </a:defRPr>
             </a:pPr>
             <a:r>
-              <a:t>Receive Interface: Instant 6-Digit Code Lookup</a:t>
+              <a:t>Transfer Dashboard: Primary Send Workspace</a:t>
             </a:r>
           </a:p>
           <a:p>
@@ -7648,14 +9036,14 @@
               </a:defRPr>
             </a:pPr>
             <a:r>
-              <a:t>Live desktop screenshot of the 6-digit code redemption workflow.</a:t>
+              <a:t>Live application screenshot of the drag &amp; drop upload interface.</a:t>
             </a:r>
           </a:p>
         </p:txBody>
       </p:sp>
       <p:pic>
         <p:nvPicPr>
-          <p:cNvPr id="5" name="Picture 4" descr="02_receive_code.png"/>
+          <p:cNvPr id="5" name="Picture 4" descr="screen_04_send_dashboard.png"/>
           <p:cNvPicPr>
             <a:picLocks noChangeAspect="1"/>
           </p:cNvPicPr>
@@ -7753,7 +9141,7 @@
               </a:defRPr>
             </a:pPr>
             <a:r>
-              <a:t>Zero-Login Receive Workflow</a:t>
+              <a:t>Send Functions &amp; Controls</a:t>
             </a:r>
           </a:p>
           <a:p>
@@ -7769,7 +9157,7 @@
               </a:defRPr>
             </a:pPr>
             <a:r>
-              <a:t>• Receiver enters a 6-digit transfer code (e.g., 839 204) to access files.</a:t>
+              <a:t>• Drag &amp; drop upload zone supporting up to 10 files simultaneously.</a:t>
             </a:r>
           </a:p>
           <a:p>
@@ -7785,7 +9173,7 @@
               </a:defRPr>
             </a:pPr>
             <a:r>
-              <a:t>• No account creation, email confirmation, or password required.</a:t>
+              <a:t>• File size presets (10 MB, 25 MB, 50 MB) and live upload progress bars.</a:t>
             </a:r>
           </a:p>
           <a:p>
@@ -7801,7 +9189,7 @@
               </a:defRPr>
             </a:pPr>
             <a:r>
-              <a:t>• Download options: Single-file download or complete ZIP archive download.</a:t>
+              <a:t>• Custom expiration timers: 1 Hour, 6 Hours, 24 Hours, 3 Days, or 7 Days.</a:t>
             </a:r>
           </a:p>
           <a:p>
@@ -7817,7 +9205,7 @@
               </a:defRPr>
             </a:pPr>
             <a:r>
-              <a:t>• Password verification prompt displayed automatically for protected shares.</a:t>
+              <a:t>• Bcrypt Password Protection: Optional password required before download.</a:t>
             </a:r>
           </a:p>
           <a:p>
@@ -7833,7 +9221,7 @@
               </a:defRPr>
             </a:pPr>
             <a:r>
-              <a:t>• Progressive rate-limiting protects against brute-force guessing attempts.</a:t>
+              <a:t>• Burn-on-Download Mode: Files automatically delete after the 1st download.</a:t>
             </a:r>
           </a:p>
           <a:p>
@@ -7849,7 +9237,7 @@
               </a:defRPr>
             </a:pPr>
             <a:r>
-              <a:t>• Instant smartphone camera pickup available via high-contrast QR code.</a:t>
+              <a:t>• Direct Inbox Option: Senders can toggle direct user inbox delivery.</a:t>
             </a:r>
           </a:p>
         </p:txBody>
@@ -7946,7 +9334,7 @@
               </a:defRPr>
             </a:pPr>
             <a:r>
-              <a:t>REAL APPLICATION INTERFACE</a:t>
+              <a:t>TRANSFER COMPLETION</a:t>
             </a:r>
           </a:p>
         </p:txBody>
@@ -7982,7 +9370,7 @@
               </a:defRPr>
             </a:pPr>
             <a:r>
-              <a:t>Direct In-App Inbox &amp; Delivery Audit Status</a:t>
+              <a:t>Share Result Screen: Code, Links &amp; Owner Key</a:t>
             </a:r>
           </a:p>
           <a:p>
@@ -7998,14 +9386,14 @@
               </a:defRPr>
             </a:pPr>
             <a:r>
-              <a:t>Live desktop screenshot of the recipient inbox management view.</a:t>
+              <a:t>Live application screenshot after completing a secure file upload.</a:t>
             </a:r>
           </a:p>
         </p:txBody>
       </p:sp>
       <p:pic>
         <p:nvPicPr>
-          <p:cNvPr id="5" name="Picture 4" descr="07_inbox_view.png"/>
+          <p:cNvPr id="5" name="Picture 4" descr="screen_05_share_result.png"/>
           <p:cNvPicPr>
             <a:picLocks noChangeAspect="1"/>
           </p:cNvPicPr>
@@ -8103,7 +9491,7 @@
               </a:defRPr>
             </a:pPr>
             <a:r>
-              <a:t>Inbox Features &amp; Audit Checkmarks</a:t>
+              <a:t>Completion Screen Functions</a:t>
             </a:r>
           </a:p>
           <a:p>
@@ -8119,7 +9507,7 @@
               </a:defRPr>
             </a:pPr>
             <a:r>
-              <a:t>• Direct user-to-user dispatch: Send files directly to @username.</a:t>
+              <a:t>• 6-Digit Quick Code Box: Receiver can enter this code to download immediately.</a:t>
             </a:r>
           </a:p>
           <a:p>
@@ -8135,7 +9523,7 @@
               </a:defRPr>
             </a:pPr>
             <a:r>
-              <a:t>• WhatsApp-style delivery status checkmarks:</a:t>
+              <a:t>• Public Download URL: 1-Click copy of the 128-bit unguessable share link.</a:t>
             </a:r>
           </a:p>
           <a:p>
@@ -8151,7 +9539,7 @@
               </a:defRPr>
             </a:pPr>
             <a:r>
-              <a:t>•   • Single tick: Sent and encrypted on server</a:t>
+              <a:t>• QR Code Modal Button: Generates high-contrast camera QR code on demand.</a:t>
             </a:r>
           </a:p>
           <a:p>
@@ -8167,7 +9555,7 @@
               </a:defRPr>
             </a:pPr>
             <a:r>
-              <a:t>•   • Double tick: Delivered to recipient's inbox queue</a:t>
+              <a:t>• 1-Click Social Sharing: Direct buttons for WhatsApp, Telegram, and Email.</a:t>
             </a:r>
           </a:p>
           <a:p>
@@ -8183,7 +9571,7 @@
               </a:defRPr>
             </a:pPr>
             <a:r>
-              <a:t>•   • Double green tick: Recipient downloaded the files</a:t>
+              <a:t>• Session Metadata Summary: Displays file count, total size, and time left.</a:t>
             </a:r>
           </a:p>
           <a:p>
@@ -8199,39 +9587,7 @@
               </a:defRPr>
             </a:pPr>
             <a:r>
-              <a:t>• Sender notes: Senders can attach instructions or context to transfers.</a:t>
-            </a:r>
-          </a:p>
-          <a:p>
-            <a:pPr>
-              <a:spcBef>
-                <a:spcPts val="600"/>
-              </a:spcBef>
-              <a:defRPr sz="1100">
-                <a:solidFill>
-                  <a:srgbClr val="E2E8F0"/>
-                </a:solidFill>
-                <a:latin typeface="Segoe UI"/>
-              </a:defRPr>
-            </a:pPr>
-            <a:r>
-              <a:t>• Inline file renaming: Recipients can customize file display names.</a:t>
-            </a:r>
-          </a:p>
-          <a:p>
-            <a:pPr>
-              <a:spcBef>
-                <a:spcPts val="600"/>
-              </a:spcBef>
-              <a:defRPr sz="1100">
-                <a:solidFill>
-                  <a:srgbClr val="E2E8F0"/>
-                </a:solidFill>
-                <a:latin typeface="Segoe UI"/>
-              </a:defRPr>
-            </a:pPr>
-            <a:r>
-              <a:t>• Batch actions: Download individual items or download all as a ZIP file.</a:t>
+              <a:t>• Secret 24-Byte Delete Key: Allows the owner to delete files early at any time.</a:t>
             </a:r>
           </a:p>
         </p:txBody>
@@ -8328,7 +9684,7 @@
               </a:defRPr>
             </a:pPr>
             <a:r>
-              <a:t>REAL APPLICATION INTERFACE</a:t>
+              <a:t>RECEIVER EXPERIENCE</a:t>
             </a:r>
           </a:p>
         </p:txBody>
@@ -8364,7 +9720,7 @@
               </a:defRPr>
             </a:pPr>
             <a:r>
-              <a:t>Study Groups &amp; Real-Time Chat Collaboration</a:t>
+              <a:t>Receive Interface: Instant 6-Digit Code Redemption</a:t>
             </a:r>
           </a:p>
           <a:p>
@@ -8380,14 +9736,14 @@
               </a:defRPr>
             </a:pPr>
             <a:r>
-              <a:t>Live desktop screenshot of team group workspaces.</a:t>
+              <a:t>Live application screenshot of the receiver code input tab.</a:t>
             </a:r>
           </a:p>
         </p:txBody>
       </p:sp>
       <p:pic>
         <p:nvPicPr>
-          <p:cNvPr id="5" name="Picture 4" descr="06_groups_view.png"/>
+          <p:cNvPr id="5" name="Picture 4" descr="screen_03_receive_code.png"/>
           <p:cNvPicPr>
             <a:picLocks noChangeAspect="1"/>
           </p:cNvPicPr>
@@ -8485,7 +9841,7 @@
               </a:defRPr>
             </a:pPr>
             <a:r>
-              <a:t>Group Collaboration Highlights</a:t>
+              <a:t>Zero-Login Receive Workflow</a:t>
             </a:r>
           </a:p>
           <a:p>
@@ -8501,7 +9857,7 @@
               </a:defRPr>
             </a:pPr>
             <a:r>
-              <a:t>• Project workspaces: Create named groups for project teams and classes.</a:t>
+              <a:t>• Receiver enters a 6-digit transfer code (e.g., 839 204) to access files.</a:t>
             </a:r>
           </a:p>
           <a:p>
@@ -8517,7 +9873,7 @@
               </a:defRPr>
             </a:pPr>
             <a:r>
-              <a:t>• Real-time chat: WhatsApp-style message bubbles with timestamps.</a:t>
+              <a:t>• No account creation, email confirmation, or password required.</a:t>
             </a:r>
           </a:p>
           <a:p>
@@ -8533,7 +9889,7 @@
               </a:defRPr>
             </a:pPr>
             <a:r>
-              <a:t>• File attachments: Attach files directly inside conversation streams.</a:t>
+              <a:t>• Download options: Single-file download or complete streaming ZIP archive.</a:t>
             </a:r>
           </a:p>
           <a:p>
@@ -8549,7 +9905,7 @@
               </a:defRPr>
             </a:pPr>
             <a:r>
-              <a:t>• Staging drawer: Preview and rename files before sending them to the group.</a:t>
+              <a:t>• Password verification prompt displayed automatically for protected shares.</a:t>
             </a:r>
           </a:p>
           <a:p>
@@ -8565,7 +9921,7 @@
               </a:defRPr>
             </a:pPr>
             <a:r>
-              <a:t>• Dedicated Files Tab: Centralized repository for all group project files.</a:t>
+              <a:t>• Progressive rate-limiting protects against brute-force guessing attempts.</a:t>
             </a:r>
           </a:p>
           <a:p>
@@ -8581,7 +9937,7 @@
               </a:defRPr>
             </a:pPr>
             <a:r>
-              <a:t>• Quick invites: 1-Click invite link sharing via WhatsApp and QR code.</a:t>
+              <a:t>• Instant smartphone camera pickup available via high-contrast QR code.</a:t>
             </a:r>
           </a:p>
         </p:txBody>
@@ -8678,7 +10034,7 @@
               </a:defRPr>
             </a:pPr>
             <a:r>
-              <a:t>REAL APPLICATION INTERFACE</a:t>
+              <a:t>DIRECT IN-APP TRANSFERS</a:t>
             </a:r>
           </a:p>
         </p:txBody>
@@ -8714,7 +10070,7 @@
               </a:defRPr>
             </a:pPr>
             <a:r>
-              <a:t>Personal Cloud Drive &amp; Storage Lifecycle</a:t>
+              <a:t>Direct In-App Inbox &amp; Delivery Audit Status</a:t>
             </a:r>
           </a:p>
           <a:p>
@@ -8730,14 +10086,14 @@
               </a:defRPr>
             </a:pPr>
             <a:r>
-              <a:t>Live desktop screenshot of the personal file management console.</a:t>
+              <a:t>Live application screenshot of the recipient inbox management view.</a:t>
             </a:r>
           </a:p>
         </p:txBody>
       </p:sp>
       <p:pic>
         <p:nvPicPr>
-          <p:cNvPr id="5" name="Picture 4" descr="05_my_files_drive.png"/>
+          <p:cNvPr id="5" name="Picture 4" descr="screen_09_inbox.png"/>
           <p:cNvPicPr>
             <a:picLocks noChangeAspect="1"/>
           </p:cNvPicPr>
@@ -8835,7 +10191,7 @@
               </a:defRPr>
             </a:pPr>
             <a:r>
-              <a:t>File Management &amp; Quota Tracking</a:t>
+              <a:t>Inbox Features &amp; Audit Checkmarks</a:t>
             </a:r>
           </a:p>
           <a:p>
@@ -8851,7 +10207,7 @@
               </a:defRPr>
             </a:pPr>
             <a:r>
-              <a:t>• Free storage quota: Live progress bar tracking usage (1024 MB quota).</a:t>
+              <a:t>• Direct user-to-user dispatch: Send files directly to @username.</a:t>
             </a:r>
           </a:p>
           <a:p>
@@ -8867,7 +10223,7 @@
               </a:defRPr>
             </a:pPr>
             <a:r>
-              <a:t>• Smart category filtering: All Files, Images, Documents, Media, and Archives.</a:t>
+              <a:t>• WhatsApp-style delivery status checkmarks:</a:t>
             </a:r>
           </a:p>
           <a:p>
@@ -8883,7 +10239,7 @@
               </a:defRPr>
             </a:pPr>
             <a:r>
-              <a:t>• Trash Bin management: Soft-delete files with 1-click instant restoration.</a:t>
+              <a:t>•   • Single tick: Sent and encrypted on server</a:t>
             </a:r>
           </a:p>
           <a:p>
@@ -8899,7 +10255,7 @@
               </a:defRPr>
             </a:pPr>
             <a:r>
-              <a:t>• Inline rename: Edit file names directly without re-uploading.</a:t>
+              <a:t>•   • Double tick: Delivered to recipient's inbox queue</a:t>
             </a:r>
           </a:p>
           <a:p>
@@ -8915,7 +10271,7 @@
               </a:defRPr>
             </a:pPr>
             <a:r>
-              <a:t>• Secret owner delete key: 24-byte cryptographic token for immediate purge.</a:t>
+              <a:t>•   • Double green tick: Recipient downloaded the files</a:t>
             </a:r>
           </a:p>
           <a:p>
@@ -8931,7 +10287,39 @@
               </a:defRPr>
             </a:pPr>
             <a:r>
-              <a:t>• Full audit details: View download counts, creation dates, and expiration times.</a:t>
+              <a:t>• Sender notes: Senders can attach instructions or context to transfers.</a:t>
+            </a:r>
+          </a:p>
+          <a:p>
+            <a:pPr>
+              <a:spcBef>
+                <a:spcPts val="600"/>
+              </a:spcBef>
+              <a:defRPr sz="1100">
+                <a:solidFill>
+                  <a:srgbClr val="E2E8F0"/>
+                </a:solidFill>
+                <a:latin typeface="Segoe UI"/>
+              </a:defRPr>
+            </a:pPr>
+            <a:r>
+              <a:t>• Inline file renaming: Recipients can customize file display names.</a:t>
+            </a:r>
+          </a:p>
+          <a:p>
+            <a:pPr>
+              <a:spcBef>
+                <a:spcPts val="600"/>
+              </a:spcBef>
+              <a:defRPr sz="1100">
+                <a:solidFill>
+                  <a:srgbClr val="E2E8F0"/>
+                </a:solidFill>
+                <a:latin typeface="Segoe UI"/>
+              </a:defRPr>
+            </a:pPr>
+            <a:r>
+              <a:t>• Batch actions: Download individual items or download all as a ZIP file.</a:t>
             </a:r>
           </a:p>
         </p:txBody>
@@ -9028,7 +10416,7 @@
               </a:defRPr>
             </a:pPr>
             <a:r>
-              <a:t>REAL APPLICATION INTERFACE</a:t>
+              <a:t>TEAM COLLABORATION</a:t>
             </a:r>
           </a:p>
         </p:txBody>
@@ -9064,7 +10452,7 @@
               </a:defRPr>
             </a:pPr>
             <a:r>
-              <a:t>Responsive Mobile Design &amp; Docked Navigation</a:t>
+              <a:t>Study Groups &amp; Real-Time Chat Collaboration</a:t>
             </a:r>
           </a:p>
           <a:p>
@@ -9080,14 +10468,14 @@
               </a:defRPr>
             </a:pPr>
             <a:r>
-              <a:t>Live mobile screenshot captured on modern smartphone viewport (390 x 844).</a:t>
+              <a:t>Live application screenshot of team group workspaces.</a:t>
             </a:r>
           </a:p>
         </p:txBody>
       </p:sp>
       <p:pic>
         <p:nvPicPr>
-          <p:cNvPr id="5" name="Picture 4" descr="03_mobile_docked_nav.png"/>
+          <p:cNvPr id="5" name="Picture 4" descr="screen_08_groups.png"/>
           <p:cNvPicPr>
             <a:picLocks noChangeAspect="1"/>
           </p:cNvPicPr>
@@ -9102,7 +10490,7 @@
         <p:spPr>
           <a:xfrm>
             <a:off x="731520" y="1645920"/>
-            <a:ext cx="3108960" cy="4572000"/>
+            <a:ext cx="6858000" cy="4572000"/>
           </a:xfrm>
           <a:prstGeom prst="rect">
             <a:avLst/>
@@ -9117,8 +10505,8 @@
         </p:nvSpPr>
         <p:spPr>
           <a:xfrm>
-            <a:off x="4114800" y="1645920"/>
-            <a:ext cx="7315200" cy="4572000"/>
+            <a:off x="7863840" y="1645920"/>
+            <a:ext cx="3566160" cy="4572000"/>
           </a:xfrm>
           <a:prstGeom prst="roundRect">
             <a:avLst/>
@@ -9162,8 +10550,8 @@
         </p:nvSpPr>
         <p:spPr>
           <a:xfrm>
-            <a:off x="4434840" y="1874519"/>
-            <a:ext cx="6675120" cy="4114800"/>
+            <a:off x="8183880" y="1874519"/>
+            <a:ext cx="2926080" cy="4114800"/>
           </a:xfrm>
           <a:prstGeom prst="rect">
             <a:avLst/>
@@ -9185,7 +10573,7 @@
               </a:defRPr>
             </a:pPr>
             <a:r>
-              <a:t>Mobile Ergonomics &amp; Responsive Polish</a:t>
+              <a:t>Group Collaboration Highlights</a:t>
             </a:r>
           </a:p>
           <a:p>
@@ -9201,7 +10589,7 @@
               </a:defRPr>
             </a:pPr>
             <a:r>
-              <a:t>• Docked bottom navigation bar: Thumb-friendly reach for all primary tabs.</a:t>
+              <a:t>• Project workspaces: Create named groups for project teams and classes.</a:t>
             </a:r>
           </a:p>
           <a:p>
@@ -9217,7 +10605,7 @@
               </a:defRPr>
             </a:pPr>
             <a:r>
-              <a:t>• Instant navigation between Transfer, Inbox, My Files, Groups, and Activity.</a:t>
+              <a:t>• Real-time chat: WhatsApp-style message bubbles with timestamps.</a:t>
             </a:r>
           </a:p>
           <a:p>
@@ -9233,7 +10621,7 @@
               </a:defRPr>
             </a:pPr>
             <a:r>
-              <a:t>• Live badge notification: Displays unread transfer count on the Inbox icon.</a:t>
+              <a:t>• File attachments: Attach files directly inside conversation streams.</a:t>
             </a:r>
           </a:p>
           <a:p>
@@ -9249,7 +10637,7 @@
               </a:defRPr>
             </a:pPr>
             <a:r>
-              <a:t>• Zero-clipping layout: Guaranteed full visibility on narrow 320px–420px screens.</a:t>
+              <a:t>• Staging drawer: Preview and rename files before sending them to the group.</a:t>
             </a:r>
           </a:p>
           <a:p>
@@ -9265,7 +10653,7 @@
               </a:defRPr>
             </a:pPr>
             <a:r>
-              <a:t>• Touch-optimized buttons: Clean touch targets prevent accidental clicks.</a:t>
+              <a:t>• Dedicated Files Tab: Centralized repository for all group project files.</a:t>
             </a:r>
           </a:p>
           <a:p>
@@ -9281,7 +10669,7 @@
               </a:defRPr>
             </a:pPr>
             <a:r>
-              <a:t>• No layout shift: Smooth, instant transitions between desktop and mobile.</a:t>
+              <a:t>• Quick invites: 1-Click invite link sharing via WhatsApp and QR code.</a:t>
             </a:r>
           </a:p>
         </p:txBody>

</xml_diff>